<commit_message>
Corrected typos in slides
</commit_message>
<xml_diff>
--- a/LectureSlides/08_IntroductionToLinearModels.pptx
+++ b/LectureSlides/08_IntroductionToLinearModels.pptx
@@ -272,7 +272,7 @@
           <a:p>
             <a:fld id="{19E36D9D-5B1A-4F71-A845-003503DCA96F}" type="datetimeFigureOut">
               <a:rPr lang="en-US" smtClean="0"/>
-              <a:t>9/25/2025</a:t>
+              <a:t>9/17/2026</a:t>
             </a:fld>
             <a:endParaRPr lang="en-US"/>
           </a:p>
@@ -802,7 +802,7 @@
           <a:p>
             <a:fld id="{241EB5C9-1307-BA42-ABA2-0BC069CD8E7F}" type="datetimeFigureOut">
               <a:rPr lang="en-US" smtClean="0"/>
-              <a:t>9/25/2025</a:t>
+              <a:t>9/17/2026</a:t>
             </a:fld>
             <a:endParaRPr lang="en-US"/>
           </a:p>
@@ -970,7 +970,7 @@
           <a:p>
             <a:fld id="{241EB5C9-1307-BA42-ABA2-0BC069CD8E7F}" type="datetimeFigureOut">
               <a:rPr lang="en-US" smtClean="0"/>
-              <a:t>9/25/2025</a:t>
+              <a:t>9/17/2026</a:t>
             </a:fld>
             <a:endParaRPr lang="en-US"/>
           </a:p>
@@ -1148,7 +1148,7 @@
           <a:p>
             <a:fld id="{241EB5C9-1307-BA42-ABA2-0BC069CD8E7F}" type="datetimeFigureOut">
               <a:rPr lang="en-US" smtClean="0"/>
-              <a:t>9/25/2025</a:t>
+              <a:t>9/17/2026</a:t>
             </a:fld>
             <a:endParaRPr lang="en-US"/>
           </a:p>
@@ -1316,7 +1316,7 @@
           <a:p>
             <a:fld id="{241EB5C9-1307-BA42-ABA2-0BC069CD8E7F}" type="datetimeFigureOut">
               <a:rPr lang="en-US" smtClean="0"/>
-              <a:t>9/25/2025</a:t>
+              <a:t>9/17/2026</a:t>
             </a:fld>
             <a:endParaRPr lang="en-US"/>
           </a:p>
@@ -1561,7 +1561,7 @@
           <a:p>
             <a:fld id="{241EB5C9-1307-BA42-ABA2-0BC069CD8E7F}" type="datetimeFigureOut">
               <a:rPr lang="en-US" smtClean="0"/>
-              <a:t>9/25/2025</a:t>
+              <a:t>9/17/2026</a:t>
             </a:fld>
             <a:endParaRPr lang="en-US"/>
           </a:p>
@@ -1846,7 +1846,7 @@
           <a:p>
             <a:fld id="{241EB5C9-1307-BA42-ABA2-0BC069CD8E7F}" type="datetimeFigureOut">
               <a:rPr lang="en-US" smtClean="0"/>
-              <a:t>9/25/2025</a:t>
+              <a:t>9/17/2026</a:t>
             </a:fld>
             <a:endParaRPr lang="en-US"/>
           </a:p>
@@ -2265,7 +2265,7 @@
           <a:p>
             <a:fld id="{241EB5C9-1307-BA42-ABA2-0BC069CD8E7F}" type="datetimeFigureOut">
               <a:rPr lang="en-US" smtClean="0"/>
-              <a:t>9/25/2025</a:t>
+              <a:t>9/17/2026</a:t>
             </a:fld>
             <a:endParaRPr lang="en-US"/>
           </a:p>
@@ -2382,7 +2382,7 @@
           <a:p>
             <a:fld id="{241EB5C9-1307-BA42-ABA2-0BC069CD8E7F}" type="datetimeFigureOut">
               <a:rPr lang="en-US" smtClean="0"/>
-              <a:t>9/25/2025</a:t>
+              <a:t>9/17/2026</a:t>
             </a:fld>
             <a:endParaRPr lang="en-US"/>
           </a:p>
@@ -2477,7 +2477,7 @@
           <a:p>
             <a:fld id="{241EB5C9-1307-BA42-ABA2-0BC069CD8E7F}" type="datetimeFigureOut">
               <a:rPr lang="en-US" smtClean="0"/>
-              <a:t>9/25/2025</a:t>
+              <a:t>9/17/2026</a:t>
             </a:fld>
             <a:endParaRPr lang="en-US"/>
           </a:p>
@@ -2752,7 +2752,7 @@
           <a:p>
             <a:fld id="{241EB5C9-1307-BA42-ABA2-0BC069CD8E7F}" type="datetimeFigureOut">
               <a:rPr lang="en-US" smtClean="0"/>
-              <a:t>9/25/2025</a:t>
+              <a:t>9/17/2026</a:t>
             </a:fld>
             <a:endParaRPr lang="en-US"/>
           </a:p>
@@ -3004,7 +3004,7 @@
           <a:p>
             <a:fld id="{241EB5C9-1307-BA42-ABA2-0BC069CD8E7F}" type="datetimeFigureOut">
               <a:rPr lang="en-US" smtClean="0"/>
-              <a:t>9/25/2025</a:t>
+              <a:t>9/17/2026</a:t>
             </a:fld>
             <a:endParaRPr lang="en-US"/>
           </a:p>
@@ -3215,7 +3215,7 @@
           <a:p>
             <a:fld id="{241EB5C9-1307-BA42-ABA2-0BC069CD8E7F}" type="datetimeFigureOut">
               <a:rPr lang="en-US" smtClean="0"/>
-              <a:t>9/25/2025</a:t>
+              <a:t>9/17/2026</a:t>
             </a:fld>
             <a:endParaRPr lang="en-US"/>
           </a:p>
@@ -3712,7 +3712,7 @@
         </p:blipFill>
         <p:spPr bwMode="auto">
           <a:xfrm>
-            <a:off x="3291067" y="3659436"/>
+            <a:off x="3291067" y="3661366"/>
             <a:ext cx="2345803" cy="965131"/>
           </a:xfrm>
           <a:prstGeom prst="rect">
@@ -3860,12 +3860,12 @@
                     <m:oMathParaPr>
                       <m:jc m:val="center"/>
                     </m:oMathParaPr>
-                    <m:oMath xmlns:m="http://schemas.openxmlformats.org/officeDocument/2006/math">
+                    <m:oMath>
                       <m:acc>
                         <m:accPr>
                           <m:chr m:val="⃗"/>
                           <m:ctrlPr>
-                            <a:rPr i="1">
+                            <a:rPr>
                               <a:latin typeface="Cambria Math" panose="02040503050406030204" pitchFamily="18" charset="0"/>
                             </a:rPr>
                           </m:ctrlPr>
@@ -3895,7 +3895,7 @@
                         <m:accPr>
                           <m:chr m:val="⃗"/>
                           <m:ctrlPr>
-                            <a:rPr i="1">
+                            <a:rPr>
                               <a:latin typeface="Cambria Math" panose="02040503050406030204" pitchFamily="18" charset="0"/>
                             </a:rPr>
                           </m:ctrlPr>
@@ -3919,7 +3919,7 @@
                         <m:accPr>
                           <m:chr m:val="⃗"/>
                           <m:ctrlPr>
-                            <a:rPr i="1">
+                            <a:rPr>
                               <a:latin typeface="Cambria Math" panose="02040503050406030204" pitchFamily="18" charset="0"/>
                             </a:rPr>
                           </m:ctrlPr>
@@ -3946,7 +3946,7 @@
                       <m:accPr>
                         <m:chr m:val="⃗"/>
                         <m:ctrlPr>
-                          <a:rPr i="1">
+                          <a:rPr>
                             <a:latin typeface="Cambria Math" panose="02040503050406030204" pitchFamily="18" charset="0"/>
                           </a:rPr>
                         </m:ctrlPr>
@@ -4461,12 +4461,12 @@
                     <m:oMathParaPr>
                       <m:jc m:val="center"/>
                     </m:oMathParaPr>
-                    <m:oMath xmlns:m="http://schemas.openxmlformats.org/officeDocument/2006/math">
+                    <m:oMath>
                       <m:acc>
                         <m:accPr>
                           <m:chr m:val="⃗"/>
                           <m:ctrlPr>
-                            <a:rPr lang="ar-AE" i="1">
+                            <a:rPr lang="ar-AE">
                               <a:latin typeface="Cambria Math" panose="02040503050406030204" pitchFamily="18" charset="0"/>
                             </a:rPr>
                           </m:ctrlPr>
@@ -4496,7 +4496,7 @@
                         <m:accPr>
                           <m:chr m:val="⃗"/>
                           <m:ctrlPr>
-                            <a:rPr lang="ar-AE" i="1">
+                            <a:rPr lang="ar-AE">
                               <a:latin typeface="Cambria Math" panose="02040503050406030204" pitchFamily="18" charset="0"/>
                             </a:rPr>
                           </m:ctrlPr>
@@ -4520,7 +4520,7 @@
                         <m:accPr>
                           <m:chr m:val="⃗"/>
                           <m:ctrlPr>
-                            <a:rPr lang="ar-AE" i="1">
+                            <a:rPr lang="ar-AE">
                               <a:latin typeface="Cambria Math" panose="02040503050406030204" pitchFamily="18" charset="0"/>
                             </a:rPr>
                           </m:ctrlPr>
@@ -4547,7 +4547,7 @@
                       <m:accPr>
                         <m:chr m:val="⃗"/>
                         <m:ctrlPr>
-                          <a:rPr lang="ar-AE" i="1">
+                          <a:rPr lang="ar-AE" b="0" i="1">
                             <a:latin typeface="Cambria Math" panose="02040503050406030204" pitchFamily="18" charset="0"/>
                           </a:rPr>
                         </m:ctrlPr>
@@ -4565,64 +4565,15 @@
                       <m:rPr>
                         <m:nor/>
                       </m:rPr>
-                      <a:rPr lang="ar-AE" dirty="0"/>
+                      <a:rPr lang="ar-AE" i="0" dirty="0"/>
                       <m:t> </m:t>
                     </m:r>
                     <m:r>
                       <m:rPr>
                         <m:nor/>
                       </m:rPr>
-                      <a:rPr lang="en-US" dirty="0"/>
-                      <m:t>is</m:t>
-                    </m:r>
-                    <m:r>
-                      <m:rPr>
-                        <m:nor/>
-                      </m:rPr>
-                      <a:rPr lang="en-US" dirty="0"/>
-                      <m:t> </m:t>
-                    </m:r>
-                    <m:r>
-                      <m:rPr>
-                        <m:nor/>
-                      </m:rPr>
-                      <a:rPr lang="en-US" dirty="0"/>
-                      <m:t>the</m:t>
-                    </m:r>
-                    <m:r>
-                      <m:rPr>
-                        <m:nor/>
-                      </m:rPr>
-                      <a:rPr lang="en-US" dirty="0"/>
-                      <m:t> </m:t>
-                    </m:r>
-                    <m:r>
-                      <m:rPr>
-                        <m:nor/>
-                      </m:rPr>
-                      <a:rPr lang="en-US" dirty="0"/>
-                      <m:t>vector</m:t>
-                    </m:r>
-                    <m:r>
-                      <m:rPr>
-                        <m:nor/>
-                      </m:rPr>
-                      <a:rPr lang="en-US" dirty="0"/>
-                      <m:t> </m:t>
-                    </m:r>
-                    <m:r>
-                      <m:rPr>
-                        <m:nor/>
-                      </m:rPr>
-                      <a:rPr lang="en-US" dirty="0"/>
-                      <m:t>of</m:t>
-                    </m:r>
-                    <m:r>
-                      <m:rPr>
-                        <m:nor/>
-                      </m:rPr>
-                      <a:rPr lang="en-US" dirty="0"/>
-                      <m:t> </m:t>
+                      <a:rPr lang="en-US" i="0" dirty="0"/>
+                      <m:t>is the vector of </m:t>
                     </m:r>
                     <m:r>
                       <a:rPr lang="en-US" b="0" i="1">
@@ -4634,29 +4585,8 @@
                       <m:rPr>
                         <m:nor/>
                       </m:rPr>
-                      <a:rPr lang="en-US" dirty="0"/>
-                      <m:t> </m:t>
-                    </m:r>
-                    <m:r>
-                      <m:rPr>
-                        <m:nor/>
-                      </m:rPr>
-                      <a:rPr lang="en-US" dirty="0"/>
-                      <m:t>model</m:t>
-                    </m:r>
-                    <m:r>
-                      <m:rPr>
-                        <m:nor/>
-                      </m:rPr>
-                      <a:rPr lang="en-US" dirty="0"/>
-                      <m:t> </m:t>
-                    </m:r>
-                    <m:r>
-                      <m:rPr>
-                        <m:nor/>
-                      </m:rPr>
-                      <a:rPr lang="en-US" dirty="0"/>
-                      <m:t>coefficients</m:t>
+                      <a:rPr lang="en-US" i="0" dirty="0"/>
+                      <m:t> model coefficients</m:t>
                     </m:r>
                   </m:oMath>
                 </a14:m>
@@ -4670,92 +4600,8 @@
                       <m:rPr>
                         <m:nor/>
                       </m:rPr>
-                      <a:rPr lang="en-US" dirty="0"/>
-                      <m:t>One</m:t>
-                    </m:r>
-                    <m:r>
-                      <m:rPr>
-                        <m:nor/>
-                      </m:rPr>
-                      <a:rPr lang="en-US" dirty="0"/>
-                      <m:t> </m:t>
-                    </m:r>
-                    <m:r>
-                      <m:rPr>
-                        <m:nor/>
-                      </m:rPr>
-                      <a:rPr lang="en-US" dirty="0"/>
-                      <m:t>coefficient</m:t>
-                    </m:r>
-                    <m:r>
-                      <m:rPr>
-                        <m:nor/>
-                      </m:rPr>
-                      <a:rPr lang="en-US" dirty="0"/>
-                      <m:t> </m:t>
-                    </m:r>
-                    <m:r>
-                      <m:rPr>
-                        <m:nor/>
-                      </m:rPr>
-                      <a:rPr lang="en-US" dirty="0"/>
-                      <m:t>for</m:t>
-                    </m:r>
-                    <m:r>
-                      <m:rPr>
-                        <m:nor/>
-                      </m:rPr>
-                      <a:rPr lang="en-US" dirty="0"/>
-                      <m:t> </m:t>
-                    </m:r>
-                    <m:r>
-                      <m:rPr>
-                        <m:nor/>
-                      </m:rPr>
-                      <a:rPr lang="en-US" dirty="0"/>
-                      <m:t>each</m:t>
-                    </m:r>
-                    <m:r>
-                      <m:rPr>
-                        <m:nor/>
-                      </m:rPr>
-                      <a:rPr lang="en-US" dirty="0"/>
-                      <m:t> </m:t>
-                    </m:r>
-                    <m:r>
-                      <m:rPr>
-                        <m:nor/>
-                      </m:rPr>
-                      <a:rPr lang="en-US" dirty="0"/>
-                      <m:t>predictor</m:t>
-                    </m:r>
-                    <m:r>
-                      <m:rPr>
-                        <m:nor/>
-                      </m:rPr>
-                      <a:rPr lang="en-US" dirty="0"/>
-                      <m:t> </m:t>
-                    </m:r>
-                    <m:r>
-                      <m:rPr>
-                        <m:nor/>
-                      </m:rPr>
-                      <a:rPr lang="en-US" dirty="0"/>
-                      <m:t>or</m:t>
-                    </m:r>
-                    <m:r>
-                      <m:rPr>
-                        <m:nor/>
-                      </m:rPr>
-                      <a:rPr lang="en-US" dirty="0"/>
-                      <m:t> </m:t>
-                    </m:r>
-                    <m:r>
-                      <m:rPr>
-                        <m:nor/>
-                      </m:rPr>
-                      <a:rPr lang="en-US" dirty="0"/>
-                      <m:t>feature</m:t>
+                      <a:rPr lang="en-US" i="0" dirty="0"/>
+                      <m:t>One coefficient for each predictor or feature</m:t>
                     </m:r>
                   </m:oMath>
                 </a14:m>
@@ -4776,148 +4622,8 @@
                       <m:rPr>
                         <m:nor/>
                       </m:rPr>
-                      <a:rPr lang="en-US" dirty="0"/>
-                      <m:t>Model</m:t>
-                    </m:r>
-                    <m:r>
-                      <m:rPr>
-                        <m:nor/>
-                      </m:rPr>
-                      <a:rPr lang="en-US" dirty="0"/>
-                      <m:t> </m:t>
-                    </m:r>
-                    <m:r>
-                      <m:rPr>
-                        <m:nor/>
-                      </m:rPr>
-                      <a:rPr lang="en-US" dirty="0"/>
-                      <m:t>is</m:t>
-                    </m:r>
-                    <m:r>
-                      <m:rPr>
-                        <m:nor/>
-                      </m:rPr>
-                      <a:rPr lang="en-US" dirty="0"/>
-                      <m:t> </m:t>
-                    </m:r>
-                    <m:r>
-                      <m:rPr>
-                        <m:nor/>
-                      </m:rPr>
-                      <a:rPr lang="en-US" dirty="0"/>
-                      <m:t>fit</m:t>
-                    </m:r>
-                    <m:r>
-                      <m:rPr>
-                        <m:nor/>
-                      </m:rPr>
-                      <a:rPr lang="en-US" dirty="0"/>
-                      <m:t> </m:t>
-                    </m:r>
-                    <m:r>
-                      <m:rPr>
-                        <m:nor/>
-                      </m:rPr>
-                      <a:rPr lang="en-US" dirty="0"/>
-                      <m:t>by</m:t>
-                    </m:r>
-                    <m:r>
-                      <m:rPr>
-                        <m:nor/>
-                      </m:rPr>
-                      <a:rPr lang="en-US" dirty="0"/>
-                      <m:t> </m:t>
-                    </m:r>
-                    <m:r>
-                      <m:rPr>
-                        <m:nor/>
-                      </m:rPr>
-                      <a:rPr lang="en-US" dirty="0"/>
-                      <m:t>finding</m:t>
-                    </m:r>
-                    <m:r>
-                      <m:rPr>
-                        <m:nor/>
-                      </m:rPr>
-                      <a:rPr lang="en-US" dirty="0"/>
-                      <m:t> </m:t>
-                    </m:r>
-                    <m:r>
-                      <m:rPr>
-                        <m:nor/>
-                      </m:rPr>
-                      <a:rPr lang="en-US" dirty="0"/>
-                      <m:t>an</m:t>
-                    </m:r>
-                    <m:r>
-                      <m:rPr>
-                        <m:nor/>
-                      </m:rPr>
-                      <a:rPr lang="en-US" dirty="0"/>
-                      <m:t> </m:t>
-                    </m:r>
-                    <m:r>
-                      <m:rPr>
-                        <m:nor/>
-                      </m:rPr>
-                      <a:rPr lang="en-US" dirty="0"/>
-                      <m:t>optimal</m:t>
-                    </m:r>
-                    <m:r>
-                      <m:rPr>
-                        <m:nor/>
-                      </m:rPr>
-                      <a:rPr lang="en-US" dirty="0"/>
-                      <m:t> </m:t>
-                    </m:r>
-                    <m:r>
-                      <m:rPr>
-                        <m:nor/>
-                      </m:rPr>
-                      <a:rPr lang="en-US" dirty="0"/>
-                      <m:t>value</m:t>
-                    </m:r>
-                    <m:r>
-                      <m:rPr>
-                        <m:nor/>
-                      </m:rPr>
-                      <a:rPr lang="en-US" dirty="0"/>
-                      <m:t> </m:t>
-                    </m:r>
-                    <m:r>
-                      <m:rPr>
-                        <m:nor/>
-                      </m:rPr>
-                      <a:rPr lang="en-US" dirty="0"/>
-                      <m:t>for</m:t>
-                    </m:r>
-                    <m:r>
-                      <m:rPr>
-                        <m:nor/>
-                      </m:rPr>
-                      <a:rPr lang="en-US" dirty="0"/>
-                      <m:t> </m:t>
-                    </m:r>
-                    <m:r>
-                      <m:rPr>
-                        <m:nor/>
-                      </m:rPr>
-                      <a:rPr lang="en-US" dirty="0"/>
-                      <m:t>each</m:t>
-                    </m:r>
-                    <m:r>
-                      <m:rPr>
-                        <m:nor/>
-                      </m:rPr>
-                      <a:rPr lang="en-US" dirty="0"/>
-                      <m:t> </m:t>
-                    </m:r>
-                    <m:r>
-                      <m:rPr>
-                        <m:nor/>
-                      </m:rPr>
-                      <a:rPr lang="en-US" dirty="0"/>
-                      <m:t>coefficient</m:t>
+                      <a:rPr lang="en-US" i="0" dirty="0"/>
+                      <m:t>Model is fit by finding an optimal value for each coefficient</m:t>
                     </m:r>
                   </m:oMath>
                 </a14:m>
@@ -4931,7 +4637,7 @@
                       <m:accPr>
                         <m:chr m:val="⃗"/>
                         <m:ctrlPr>
-                          <a:rPr lang="ar-AE" i="1">
+                          <a:rPr lang="ar-AE" b="0" i="1">
                             <a:latin typeface="Cambria Math" panose="02040503050406030204" pitchFamily="18" charset="0"/>
                           </a:rPr>
                         </m:ctrlPr>
@@ -4993,7 +4699,7 @@
                     <m:d>
                       <m:dPr>
                         <m:ctrlPr>
-                          <a:rPr lang="ar-AE" i="1">
+                          <a:rPr lang="ar-AE" b="0" i="1">
                             <a:latin typeface="Cambria Math" panose="02040503050406030204" pitchFamily="18" charset="0"/>
                           </a:rPr>
                         </m:ctrlPr>
@@ -5014,7 +4720,7 @@
                         <m:sSup>
                           <m:sSupPr>
                             <m:ctrlPr>
-                              <a:rPr lang="ar-AE" i="1">
+                              <a:rPr lang="ar-AE" b="0" i="1">
                                 <a:latin typeface="Cambria Math" panose="02040503050406030204" pitchFamily="18" charset="0"/>
                               </a:rPr>
                             </m:ctrlPr>
@@ -5624,12 +5330,12 @@
                     <m:oMathParaPr>
                       <m:jc m:val="center"/>
                     </m:oMathParaPr>
-                    <m:oMath xmlns:m="http://schemas.openxmlformats.org/officeDocument/2006/math">
+                    <m:oMath>
                       <m:acc>
                         <m:accPr>
                           <m:chr m:val="⃗"/>
                           <m:ctrlPr>
-                            <a:rPr lang="ar-AE" i="1">
+                            <a:rPr lang="ar-AE">
                               <a:latin typeface="Cambria Math" panose="02040503050406030204" pitchFamily="18" charset="0"/>
                             </a:rPr>
                           </m:ctrlPr>
@@ -5659,7 +5365,7 @@
                         <m:accPr>
                           <m:chr m:val="⃗"/>
                           <m:ctrlPr>
-                            <a:rPr lang="ar-AE" i="1">
+                            <a:rPr lang="ar-AE">
                               <a:latin typeface="Cambria Math" panose="02040503050406030204" pitchFamily="18" charset="0"/>
                             </a:rPr>
                           </m:ctrlPr>
@@ -5683,7 +5389,7 @@
                         <m:accPr>
                           <m:chr m:val="⃗"/>
                           <m:ctrlPr>
-                            <a:rPr lang="ar-AE" i="1">
+                            <a:rPr lang="ar-AE">
                               <a:latin typeface="Cambria Math" panose="02040503050406030204" pitchFamily="18" charset="0"/>
                             </a:rPr>
                           </m:ctrlPr>
@@ -5946,7 +5652,7 @@
                       <m:accPr>
                         <m:chr m:val="⃗"/>
                         <m:ctrlPr>
-                          <a:rPr lang="ar-AE" i="1">
+                          <a:rPr lang="ar-AE">
                             <a:latin typeface="Cambria Math" panose="02040503050406030204" pitchFamily="18" charset="0"/>
                           </a:rPr>
                         </m:ctrlPr>
@@ -6170,13 +5876,7 @@
                       <a:rPr lang="en-US">
                         <a:latin typeface="Cambria Math" panose="02040503050406030204" pitchFamily="18" charset="0"/>
                       </a:rPr>
-                      <m:t>=</m:t>
-                    </m:r>
-                    <m:r>
-                      <a:rPr lang="en-US">
-                        <a:latin typeface="Cambria Math" panose="02040503050406030204" pitchFamily="18" charset="0"/>
-                      </a:rPr>
-                      <m:t>2</m:t>
+                      <m:t>=2</m:t>
                     </m:r>
                   </m:oMath>
                 </a14:m>
@@ -6194,12 +5894,12 @@
                     <m:oMathParaPr>
                       <m:jc m:val="center"/>
                     </m:oMathParaPr>
-                    <m:oMath xmlns:m="http://schemas.openxmlformats.org/officeDocument/2006/math">
+                    <m:oMath>
                       <m:acc>
                         <m:accPr>
                           <m:chr m:val="⃗"/>
                           <m:ctrlPr>
-                            <a:rPr lang="ar-AE" i="1">
+                            <a:rPr lang="ar-AE">
                               <a:latin typeface="Cambria Math" panose="02040503050406030204" pitchFamily="18" charset="0"/>
                             </a:rPr>
                           </m:ctrlPr>
@@ -6251,7 +5951,7 @@
                                 <m:sSub>
                                   <m:sSubPr>
                                     <m:ctrlPr>
-                                      <a:rPr lang="ar-AE" i="1">
+                                      <a:rPr lang="ar-AE">
                                         <a:latin typeface="Cambria Math" panose="02040503050406030204" pitchFamily="18" charset="0"/>
                                       </a:rPr>
                                     </m:ctrlPr>
@@ -6280,7 +5980,7 @@
                                 <m:sSub>
                                   <m:sSubPr>
                                     <m:ctrlPr>
-                                      <a:rPr lang="ar-AE" i="1" smtClean="0">
+                                      <a:rPr lang="ar-AE">
                                         <a:latin typeface="Cambria Math" panose="02040503050406030204" pitchFamily="18" charset="0"/>
                                       </a:rPr>
                                     </m:ctrlPr>
@@ -6387,7 +6087,7 @@
                         <m:limLow>
                           <m:limLowPr>
                             <m:ctrlPr>
-                              <a:rPr lang="ar-AE" i="1">
+                              <a:rPr lang="en-US">
                                 <a:latin typeface="Cambria Math" panose="02040503050406030204" pitchFamily="18" charset="0"/>
                               </a:rPr>
                             </m:ctrlPr>
@@ -6408,7 +6108,7 @@
                               <m:accPr>
                                 <m:chr m:val="⃗"/>
                                 <m:ctrlPr>
-                                  <a:rPr lang="ar-AE" i="1">
+                                  <a:rPr lang="ar-AE">
                                     <a:latin typeface="Cambria Math" panose="02040503050406030204" pitchFamily="18" charset="0"/>
                                   </a:rPr>
                                 </m:ctrlPr>
@@ -6431,7 +6131,7 @@
                             <m:chr m:val="∑"/>
                             <m:supHide m:val="on"/>
                             <m:ctrlPr>
-                              <a:rPr lang="ar-AE" i="1" smtClean="0">
+                              <a:rPr lang="en-US" b="0" i="1" smtClean="0">
                                 <a:latin typeface="Cambria Math" panose="02040503050406030204" pitchFamily="18" charset="0"/>
                               </a:rPr>
                             </m:ctrlPr>
@@ -6454,6 +6154,7 @@
                                 <m:ctrlPr>
                                   <a:rPr lang="ar-AE" i="1" smtClean="0">
                                     <a:latin typeface="Cambria Math" panose="02040503050406030204" pitchFamily="18" charset="0"/>
+                                    <a:ea typeface="Cambria Math" panose="02040503050406030204" pitchFamily="18" charset="0"/>
                                   </a:rPr>
                                 </m:ctrlPr>
                               </m:sSubSupPr>
@@ -6516,7 +6217,7 @@
                     <m:sSub>
                       <m:sSubPr>
                         <m:ctrlPr>
-                          <a:rPr lang="ar-AE" i="1">
+                          <a:rPr lang="ar-AE">
                             <a:latin typeface="Cambria Math" panose="02040503050406030204" pitchFamily="18" charset="0"/>
                           </a:rPr>
                         </m:ctrlPr>
@@ -6591,13 +6292,7 @@
                       <a:rPr lang="en-US">
                         <a:latin typeface="Cambria Math" panose="02040503050406030204" pitchFamily="18" charset="0"/>
                       </a:rPr>
-                      <m:t>=</m:t>
-                    </m:r>
-                    <m:r>
-                      <a:rPr lang="en-US">
-                        <a:latin typeface="Cambria Math" panose="02040503050406030204" pitchFamily="18" charset="0"/>
-                      </a:rPr>
-                      <m:t>0</m:t>
+                      <m:t>=0</m:t>
                     </m:r>
                   </m:oMath>
                 </a14:m>
@@ -6610,7 +6305,7 @@
                     <m:sSub>
                       <m:sSubPr>
                         <m:ctrlPr>
-                          <a:rPr lang="ar-AE" i="1" smtClean="0">
+                          <a:rPr lang="ar-AE">
                             <a:latin typeface="Cambria Math" panose="02040503050406030204" pitchFamily="18" charset="0"/>
                           </a:rPr>
                         </m:ctrlPr>
@@ -6672,7 +6367,7 @@
                     <m:d>
                       <m:dPr>
                         <m:ctrlPr>
-                          <a:rPr lang="en-US" b="0" i="1" smtClean="0">
+                          <a:rPr lang="en-US">
                             <a:latin typeface="Cambria Math" panose="02040503050406030204" pitchFamily="18" charset="0"/>
                           </a:rPr>
                         </m:ctrlPr>
@@ -6690,13 +6385,7 @@
                       <a:rPr lang="en-US" b="0" i="0" smtClean="0">
                         <a:latin typeface="Cambria Math" panose="02040503050406030204" pitchFamily="18" charset="0"/>
                       </a:rPr>
-                      <m:t>=</m:t>
-                    </m:r>
-                    <m:r>
-                      <a:rPr lang="en-US" b="0" i="0" smtClean="0">
-                        <a:latin typeface="Cambria Math" panose="02040503050406030204" pitchFamily="18" charset="0"/>
-                      </a:rPr>
-                      <m:t>0</m:t>
+                      <m:t>=0</m:t>
                     </m:r>
                   </m:oMath>
                 </a14:m>
@@ -6716,7 +6405,7 @@
                     <m:sSub>
                       <m:sSubPr>
                         <m:ctrlPr>
-                          <a:rPr lang="ar-AE" i="1" smtClean="0">
+                          <a:rPr lang="ar-AE">
                             <a:latin typeface="Cambria Math" panose="02040503050406030204" pitchFamily="18" charset="0"/>
                           </a:rPr>
                         </m:ctrlPr>
@@ -6782,7 +6471,7 @@
                     <m:sSub>
                       <m:sSubPr>
                         <m:ctrlPr>
-                          <a:rPr lang="ar-AE" i="1" smtClean="0">
+                          <a:rPr lang="ar-AE">
                             <a:latin typeface="Cambria Math" panose="02040503050406030204" pitchFamily="18" charset="0"/>
                           </a:rPr>
                         </m:ctrlPr>
@@ -6853,7 +6542,7 @@
                     <m:sSub>
                       <m:sSubPr>
                         <m:ctrlPr>
-                          <a:rPr lang="ar-AE" i="1">
+                          <a:rPr lang="ar-AE">
                             <a:latin typeface="Cambria Math" panose="02040503050406030204" pitchFamily="18" charset="0"/>
                           </a:rPr>
                         </m:ctrlPr>
@@ -7458,7 +7147,7 @@
                     <m:sSub>
                       <m:sSubPr>
                         <m:ctrlPr>
-                          <a:rPr lang="ar-AE" i="1">
+                          <a:rPr lang="ar-AE">
                             <a:latin typeface="Cambria Math" panose="02040503050406030204" pitchFamily="18" charset="0"/>
                           </a:rPr>
                         </m:ctrlPr>
@@ -7505,7 +7194,7 @@
                           <m:accPr>
                             <m:chr m:val="̂"/>
                             <m:ctrlPr>
-                              <a:rPr lang="ar-AE" i="1">
+                              <a:rPr lang="ar-AE">
                                 <a:latin typeface="Cambria Math" panose="02040503050406030204" pitchFamily="18" charset="0"/>
                               </a:rPr>
                             </m:ctrlPr>
@@ -7546,10 +7235,7 @@
                 </a:pPr>
                 <a14:m>
                   <m:oMathPara xmlns:m="http://schemas.openxmlformats.org/officeDocument/2006/math">
-                    <m:oMathParaPr>
-                      <m:jc m:val="centerGroup"/>
-                    </m:oMathParaPr>
-                    <m:oMath xmlns:m="http://schemas.openxmlformats.org/officeDocument/2006/math">
+                    <m:oMath>
                       <m:sSub>
                         <m:sSubPr>
                           <m:ctrlPr>
@@ -7563,7 +7249,7 @@
                             <m:accPr>
                               <m:chr m:val="̂"/>
                               <m:ctrlPr>
-                                <a:rPr lang="ar-AE" i="1" smtClean="0">
+                                <a:rPr lang="en-US" b="0" i="1" smtClean="0">
                                   <a:latin typeface="Cambria Math" panose="02040503050406030204" pitchFamily="18" charset="0"/>
                                 </a:rPr>
                               </m:ctrlPr>
@@ -7596,7 +7282,7 @@
                       <m:sSub>
                         <m:sSubPr>
                           <m:ctrlPr>
-                            <a:rPr lang="ar-AE" i="1">
+                            <a:rPr lang="ar-AE">
                               <a:latin typeface="Cambria Math" panose="02040503050406030204" pitchFamily="18" charset="0"/>
                             </a:rPr>
                           </m:ctrlPr>
@@ -7627,7 +7313,7 @@
                       <m:sSub>
                         <m:sSubPr>
                           <m:ctrlPr>
-                            <a:rPr lang="ar-AE" i="1">
+                            <a:rPr lang="ar-AE">
                               <a:latin typeface="Cambria Math" panose="02040503050406030204" pitchFamily="18" charset="0"/>
                             </a:rPr>
                           </m:ctrlPr>
@@ -7652,7 +7338,7 @@
                       <m:sSub>
                         <m:sSubPr>
                           <m:ctrlPr>
-                            <a:rPr lang="ar-AE" i="1" smtClean="0">
+                            <a:rPr lang="en-US" b="0" i="1" smtClean="0">
                               <a:latin typeface="Cambria Math" panose="02040503050406030204" pitchFamily="18" charset="0"/>
                             </a:rPr>
                           </m:ctrlPr>
@@ -7685,15 +7371,13 @@
                 </a:pPr>
                 <a14:m>
                   <m:oMathPara xmlns:m="http://schemas.openxmlformats.org/officeDocument/2006/math">
-                    <m:oMathParaPr>
-                      <m:jc m:val="centerGroup"/>
-                    </m:oMathParaPr>
-                    <m:oMath xmlns:m="http://schemas.openxmlformats.org/officeDocument/2006/math">
+                    <m:oMath>
                       <m:sSub>
                         <m:sSubPr>
                           <m:ctrlPr>
                             <a:rPr lang="ar-AE" i="1" smtClean="0">
                               <a:latin typeface="Cambria Math" panose="02040503050406030204" pitchFamily="18" charset="0"/>
+                              <a:ea typeface="Cambria Math" panose="02040503050406030204" pitchFamily="18" charset="0"/>
                             </a:rPr>
                           </m:ctrlPr>
                         </m:sSubPr>
@@ -7765,7 +7449,7 @@
                             <m:accPr>
                               <m:chr m:val="̂"/>
                               <m:ctrlPr>
-                                <a:rPr lang="ar-AE" i="1">
+                                <a:rPr lang="en-US" i="1">
                                   <a:latin typeface="Cambria Math" panose="02040503050406030204" pitchFamily="18" charset="0"/>
                                 </a:rPr>
                               </m:ctrlPr>
@@ -7800,15 +7484,13 @@
                 </a:pPr>
                 <a14:m>
                   <m:oMathPara xmlns:m="http://schemas.openxmlformats.org/officeDocument/2006/math">
-                    <m:oMathParaPr>
-                      <m:jc m:val="centerGroup"/>
-                    </m:oMathParaPr>
-                    <m:oMath xmlns:m="http://schemas.openxmlformats.org/officeDocument/2006/math">
+                    <m:oMath>
                       <m:sSub>
                         <m:sSubPr>
                           <m:ctrlPr>
                             <a:rPr lang="ar-AE" i="1">
                               <a:latin typeface="Cambria Math" panose="02040503050406030204" pitchFamily="18" charset="0"/>
+                              <a:ea typeface="Cambria Math" panose="02040503050406030204" pitchFamily="18" charset="0"/>
                             </a:rPr>
                           </m:ctrlPr>
                         </m:sSubPr>
@@ -7859,14 +7541,7 @@
                               <a:latin typeface="Cambria Math" panose="02040503050406030204" pitchFamily="18" charset="0"/>
                               <a:ea typeface="Cambria Math" panose="02040503050406030204" pitchFamily="18" charset="0"/>
                             </a:rPr>
-                            <m:t>0</m:t>
-                          </m:r>
-                          <m:r>
-                            <a:rPr lang="en-US" b="0" i="1" smtClean="0">
-                              <a:latin typeface="Cambria Math" panose="02040503050406030204" pitchFamily="18" charset="0"/>
-                              <a:ea typeface="Cambria Math" panose="02040503050406030204" pitchFamily="18" charset="0"/>
-                            </a:rPr>
-                            <m:t>,</m:t>
+                            <m:t>0,</m:t>
                           </m:r>
                           <m:sSup>
                             <m:sSupPr>
@@ -7910,7 +7585,7 @@
                     <m:sSub>
                       <m:sSubPr>
                         <m:ctrlPr>
-                          <a:rPr lang="ar-AE" i="1">
+                          <a:rPr lang="ar-AE">
                             <a:latin typeface="Cambria Math" panose="02040503050406030204" pitchFamily="18" charset="0"/>
                           </a:rPr>
                         </m:ctrlPr>
@@ -7964,10 +7639,7 @@
                 </a:pPr>
                 <a14:m>
                   <m:oMathPara xmlns:m="http://schemas.openxmlformats.org/officeDocument/2006/math">
-                    <m:oMathParaPr>
-                      <m:jc m:val="centerGroup"/>
-                    </m:oMathParaPr>
-                    <m:oMath xmlns:m="http://schemas.openxmlformats.org/officeDocument/2006/math">
+                    <m:oMath>
                       <m:r>
                         <a:rPr lang="en-US">
                           <a:latin typeface="Cambria Math" panose="02040503050406030204" pitchFamily="18" charset="0"/>
@@ -7986,7 +7658,7 @@
                           <m:sSub>
                             <m:sSubPr>
                               <m:ctrlPr>
-                                <a:rPr lang="ar-AE" i="1">
+                                <a:rPr lang="ar-AE">
                                   <a:latin typeface="Cambria Math" panose="02040503050406030204" pitchFamily="18" charset="0"/>
                                 </a:rPr>
                               </m:ctrlPr>
@@ -8014,13 +7686,7 @@
                         <a:rPr lang="ar-AE">
                           <a:latin typeface="Cambria Math" panose="02040503050406030204" pitchFamily="18" charset="0"/>
                         </a:rPr>
-                        <m:t>=</m:t>
-                      </m:r>
-                      <m:r>
-                        <a:rPr lang="ar-AE">
-                          <a:latin typeface="Cambria Math" panose="02040503050406030204" pitchFamily="18" charset="0"/>
-                        </a:rPr>
-                        <m:t>0</m:t>
+                        <m:t>=0</m:t>
                       </m:r>
                     </m:oMath>
                   </m:oMathPara>
@@ -8623,7 +8289,7 @@
                     <m:d>
                       <m:dPr>
                         <m:ctrlPr>
-                          <a:rPr i="1">
+                          <a:rPr>
                             <a:latin typeface="Cambria Math" panose="02040503050406030204" pitchFamily="18" charset="0"/>
                           </a:rPr>
                         </m:ctrlPr>
@@ -8633,19 +8299,7 @@
                           <a:rPr>
                             <a:latin typeface="Cambria Math" panose="02040503050406030204" pitchFamily="18" charset="0"/>
                           </a:rPr>
-                          <m:t>0</m:t>
-                        </m:r>
-                        <m:r>
-                          <a:rPr>
-                            <a:latin typeface="Cambria Math" panose="02040503050406030204" pitchFamily="18" charset="0"/>
-                          </a:rPr>
-                          <m:t>,</m:t>
-                        </m:r>
-                        <m:r>
-                          <a:rPr>
-                            <a:latin typeface="Cambria Math" panose="02040503050406030204" pitchFamily="18" charset="0"/>
-                          </a:rPr>
-                          <m:t>2</m:t>
+                          <m:t>0,2</m:t>
                         </m:r>
                       </m:e>
                     </m:d>
@@ -8665,13 +8319,7 @@
                       <a:rPr>
                         <a:latin typeface="Cambria Math" panose="02040503050406030204" pitchFamily="18" charset="0"/>
                       </a:rPr>
-                      <m:t>=</m:t>
-                    </m:r>
-                    <m:r>
-                      <a:rPr>
-                        <a:latin typeface="Cambria Math" panose="02040503050406030204" pitchFamily="18" charset="0"/>
-                      </a:rPr>
-                      <m:t>0</m:t>
+                      <m:t>=0</m:t>
                     </m:r>
                   </m:oMath>
                 </a14:m>
@@ -8685,25 +8333,7 @@
                       <a:rPr>
                         <a:latin typeface="Cambria Math" panose="02040503050406030204" pitchFamily="18" charset="0"/>
                       </a:rPr>
-                      <m:t>=</m:t>
-                    </m:r>
-                    <m:r>
-                      <a:rPr>
-                        <a:latin typeface="Cambria Math" panose="02040503050406030204" pitchFamily="18" charset="0"/>
-                      </a:rPr>
-                      <m:t>1</m:t>
-                    </m:r>
-                    <m:r>
-                      <a:rPr>
-                        <a:latin typeface="Cambria Math" panose="02040503050406030204" pitchFamily="18" charset="0"/>
-                      </a:rPr>
-                      <m:t>.</m:t>
-                    </m:r>
-                    <m:r>
-                      <a:rPr>
-                        <a:latin typeface="Cambria Math" panose="02040503050406030204" pitchFamily="18" charset="0"/>
-                      </a:rPr>
-                      <m:t>0</m:t>
+                      <m:t>=1.0</m:t>
                     </m:r>
                   </m:oMath>
                 </a14:m>
@@ -8958,7 +8588,7 @@
                     <m:oMathParaPr>
                       <m:jc m:val="center"/>
                     </m:oMathParaPr>
-                    <m:oMath xmlns:m="http://schemas.openxmlformats.org/officeDocument/2006/math">
+                    <m:oMath>
                       <m:d>
                         <m:dPr>
                           <m:begChr m:val="["/>
@@ -8991,7 +8621,7 @@
                                 <m:sSub>
                                   <m:sSubPr>
                                     <m:ctrlPr>
-                                      <a:rPr i="1">
+                                      <a:rPr>
                                         <a:latin typeface="Cambria Math" panose="02040503050406030204" pitchFamily="18" charset="0"/>
                                       </a:rPr>
                                     </m:ctrlPr>
@@ -9022,7 +8652,7 @@
                                 <m:sSub>
                                   <m:sSubPr>
                                     <m:ctrlPr>
-                                      <a:rPr i="1">
+                                      <a:rPr>
                                         <a:latin typeface="Cambria Math" panose="02040503050406030204" pitchFamily="18" charset="0"/>
                                       </a:rPr>
                                     </m:ctrlPr>
@@ -9051,7 +8681,7 @@
                                 <m:sSub>
                                   <m:sSubPr>
                                     <m:ctrlPr>
-                                      <a:rPr i="1">
+                                      <a:rPr>
                                         <a:latin typeface="Cambria Math" panose="02040503050406030204" pitchFamily="18" charset="0"/>
                                       </a:rPr>
                                     </m:ctrlPr>
@@ -9082,7 +8712,7 @@
                                 <m:sSub>
                                   <m:sSubPr>
                                     <m:ctrlPr>
-                                      <a:rPr i="1">
+                                      <a:rPr>
                                         <a:latin typeface="Cambria Math" panose="02040503050406030204" pitchFamily="18" charset="0"/>
                                       </a:rPr>
                                     </m:ctrlPr>
@@ -9111,7 +8741,7 @@
                                 <m:sSub>
                                   <m:sSubPr>
                                     <m:ctrlPr>
-                                      <a:rPr i="1">
+                                      <a:rPr>
                                         <a:latin typeface="Cambria Math" panose="02040503050406030204" pitchFamily="18" charset="0"/>
                                       </a:rPr>
                                     </m:ctrlPr>
@@ -9142,7 +8772,7 @@
                                 <m:sSub>
                                   <m:sSubPr>
                                     <m:ctrlPr>
-                                      <a:rPr i="1">
+                                      <a:rPr>
                                         <a:latin typeface="Cambria Math" panose="02040503050406030204" pitchFamily="18" charset="0"/>
                                       </a:rPr>
                                     </m:ctrlPr>
@@ -9181,7 +8811,7 @@
                                 <m:sSub>
                                   <m:sSubPr>
                                     <m:ctrlPr>
-                                      <a:rPr i="1">
+                                      <a:rPr>
                                         <a:latin typeface="Cambria Math" panose="02040503050406030204" pitchFamily="18" charset="0"/>
                                       </a:rPr>
                                     </m:ctrlPr>
@@ -9212,7 +8842,7 @@
                                 <m:sSub>
                                   <m:sSubPr>
                                     <m:ctrlPr>
-                                      <a:rPr i="1">
+                                      <a:rPr>
                                         <a:latin typeface="Cambria Math" panose="02040503050406030204" pitchFamily="18" charset="0"/>
                                       </a:rPr>
                                     </m:ctrlPr>
@@ -9584,7 +9214,7 @@
                     <m:oMathParaPr>
                       <m:jc m:val="center"/>
                     </m:oMathParaPr>
-                    <m:oMath xmlns:m="http://schemas.openxmlformats.org/officeDocument/2006/math">
+                    <m:oMath>
                       <m:d>
                         <m:dPr>
                           <m:begChr m:val="["/>
@@ -9618,18 +9248,12 @@
                                   <a:rPr>
                                     <a:latin typeface="Cambria Math" panose="02040503050406030204" pitchFamily="18" charset="0"/>
                                   </a:rPr>
-                                  <m:t>1</m:t>
-                                </m:r>
-                                <m:r>
-                                  <a:rPr>
-                                    <a:latin typeface="Cambria Math" panose="02040503050406030204" pitchFamily="18" charset="0"/>
-                                  </a:rPr>
-                                  <m:t>,</m:t>
+                                  <m:t>1,</m:t>
                                 </m:r>
                                 <m:sSub>
                                   <m:sSubPr>
                                     <m:ctrlPr>
-                                      <a:rPr i="1">
+                                      <a:rPr>
                                         <a:latin typeface="Cambria Math" panose="02040503050406030204" pitchFamily="18" charset="0"/>
                                       </a:rPr>
                                     </m:ctrlPr>
@@ -9659,18 +9283,12 @@
                                   <a:rPr>
                                     <a:latin typeface="Cambria Math" panose="02040503050406030204" pitchFamily="18" charset="0"/>
                                   </a:rPr>
-                                  <m:t>1</m:t>
-                                </m:r>
-                                <m:r>
-                                  <a:rPr>
-                                    <a:latin typeface="Cambria Math" panose="02040503050406030204" pitchFamily="18" charset="0"/>
-                                  </a:rPr>
-                                  <m:t>,</m:t>
+                                  <m:t>1,</m:t>
                                 </m:r>
                                 <m:sSub>
                                   <m:sSubPr>
                                     <m:ctrlPr>
-                                      <a:rPr i="1">
+                                      <a:rPr>
                                         <a:latin typeface="Cambria Math" panose="02040503050406030204" pitchFamily="18" charset="0"/>
                                       </a:rPr>
                                     </m:ctrlPr>
@@ -9700,18 +9318,12 @@
                                   <a:rPr>
                                     <a:latin typeface="Cambria Math" panose="02040503050406030204" pitchFamily="18" charset="0"/>
                                   </a:rPr>
-                                  <m:t>1</m:t>
-                                </m:r>
-                                <m:r>
-                                  <a:rPr>
-                                    <a:latin typeface="Cambria Math" panose="02040503050406030204" pitchFamily="18" charset="0"/>
-                                  </a:rPr>
-                                  <m:t>,</m:t>
+                                  <m:t>1,</m:t>
                                 </m:r>
                                 <m:sSub>
                                   <m:sSubPr>
                                     <m:ctrlPr>
-                                      <a:rPr i="1">
+                                      <a:rPr>
                                         <a:latin typeface="Cambria Math" panose="02040503050406030204" pitchFamily="18" charset="0"/>
                                       </a:rPr>
                                     </m:ctrlPr>
@@ -9751,18 +9363,12 @@
                                   <a:rPr>
                                     <a:latin typeface="Cambria Math" panose="02040503050406030204" pitchFamily="18" charset="0"/>
                                   </a:rPr>
-                                  <m:t>1</m:t>
-                                </m:r>
-                                <m:r>
-                                  <a:rPr>
-                                    <a:latin typeface="Cambria Math" panose="02040503050406030204" pitchFamily="18" charset="0"/>
-                                  </a:rPr>
-                                  <m:t>,</m:t>
+                                  <m:t>1,</m:t>
                                 </m:r>
                                 <m:sSub>
                                   <m:sSubPr>
                                     <m:ctrlPr>
-                                      <a:rPr i="1">
+                                      <a:rPr>
                                         <a:latin typeface="Cambria Math" panose="02040503050406030204" pitchFamily="18" charset="0"/>
                                       </a:rPr>
                                     </m:ctrlPr>
@@ -9952,7 +9558,7 @@
                       <m:accPr>
                         <m:chr m:val="⃗"/>
                         <m:ctrlPr>
-                          <a:rPr sz="2000" i="1">
+                          <a:rPr sz="2000">
                             <a:latin typeface="Cambria Math" panose="02040503050406030204" pitchFamily="18" charset="0"/>
                           </a:rPr>
                         </m:ctrlPr>
@@ -9982,7 +9588,7 @@
                     <m:oMathParaPr>
                       <m:jc m:val="center"/>
                     </m:oMathParaPr>
-                    <m:oMath xmlns:m="http://schemas.openxmlformats.org/officeDocument/2006/math">
+                    <m:oMath>
                       <m:d>
                         <m:dPr>
                           <m:begChr m:val="["/>
@@ -10015,7 +9621,7 @@
                                 <m:sSub>
                                   <m:sSubPr>
                                     <m:ctrlPr>
-                                      <a:rPr sz="2000" i="1">
+                                      <a:rPr sz="2000">
                                         <a:latin typeface="Cambria Math" panose="02040503050406030204" pitchFamily="18" charset="0"/>
                                       </a:rPr>
                                     </m:ctrlPr>
@@ -10044,7 +9650,7 @@
                                 <m:sSub>
                                   <m:sSubPr>
                                     <m:ctrlPr>
-                                      <a:rPr sz="2000" i="1">
+                                      <a:rPr sz="2000">
                                         <a:latin typeface="Cambria Math" panose="02040503050406030204" pitchFamily="18" charset="0"/>
                                       </a:rPr>
                                     </m:ctrlPr>
@@ -10073,7 +9679,7 @@
                                 <m:sSub>
                                   <m:sSubPr>
                                     <m:ctrlPr>
-                                      <a:rPr sz="2000" i="1">
+                                      <a:rPr sz="2000">
                                         <a:latin typeface="Cambria Math" panose="02040503050406030204" pitchFamily="18" charset="0"/>
                                       </a:rPr>
                                     </m:ctrlPr>
@@ -10112,7 +9718,7 @@
                                 <m:sSub>
                                   <m:sSubPr>
                                     <m:ctrlPr>
-                                      <a:rPr sz="2000" i="1">
+                                      <a:rPr sz="2000">
                                         <a:latin typeface="Cambria Math" panose="02040503050406030204" pitchFamily="18" charset="0"/>
                                       </a:rPr>
                                     </m:ctrlPr>
@@ -10178,18 +9784,12 @@
                                   <a:rPr sz="2000">
                                     <a:latin typeface="Cambria Math" panose="02040503050406030204" pitchFamily="18" charset="0"/>
                                   </a:rPr>
-                                  <m:t>1</m:t>
-                                </m:r>
-                                <m:r>
-                                  <a:rPr sz="2000">
-                                    <a:latin typeface="Cambria Math" panose="02040503050406030204" pitchFamily="18" charset="0"/>
-                                  </a:rPr>
-                                  <m:t>,</m:t>
+                                  <m:t>1,</m:t>
                                 </m:r>
                                 <m:sSub>
                                   <m:sSubPr>
                                     <m:ctrlPr>
-                                      <a:rPr sz="2000" i="1">
+                                      <a:rPr sz="2000">
                                         <a:latin typeface="Cambria Math" panose="02040503050406030204" pitchFamily="18" charset="0"/>
                                       </a:rPr>
                                     </m:ctrlPr>
@@ -10219,18 +9819,12 @@
                                   <a:rPr sz="2000">
                                     <a:latin typeface="Cambria Math" panose="02040503050406030204" pitchFamily="18" charset="0"/>
                                   </a:rPr>
-                                  <m:t>1</m:t>
-                                </m:r>
-                                <m:r>
-                                  <a:rPr sz="2000">
-                                    <a:latin typeface="Cambria Math" panose="02040503050406030204" pitchFamily="18" charset="0"/>
-                                  </a:rPr>
-                                  <m:t>,</m:t>
+                                  <m:t>1,</m:t>
                                 </m:r>
                                 <m:sSub>
                                   <m:sSubPr>
                                     <m:ctrlPr>
-                                      <a:rPr sz="2000" i="1">
+                                      <a:rPr sz="2000">
                                         <a:latin typeface="Cambria Math" panose="02040503050406030204" pitchFamily="18" charset="0"/>
                                       </a:rPr>
                                     </m:ctrlPr>
@@ -10260,18 +9854,12 @@
                                   <a:rPr sz="2000">
                                     <a:latin typeface="Cambria Math" panose="02040503050406030204" pitchFamily="18" charset="0"/>
                                   </a:rPr>
-                                  <m:t>1</m:t>
-                                </m:r>
-                                <m:r>
-                                  <a:rPr sz="2000">
-                                    <a:latin typeface="Cambria Math" panose="02040503050406030204" pitchFamily="18" charset="0"/>
-                                  </a:rPr>
-                                  <m:t>,</m:t>
+                                  <m:t>1,</m:t>
                                 </m:r>
                                 <m:sSub>
                                   <m:sSubPr>
                                     <m:ctrlPr>
-                                      <a:rPr sz="2000" i="1">
+                                      <a:rPr sz="2000">
                                         <a:latin typeface="Cambria Math" panose="02040503050406030204" pitchFamily="18" charset="0"/>
                                       </a:rPr>
                                     </m:ctrlPr>
@@ -10311,18 +9899,12 @@
                                   <a:rPr sz="2000">
                                     <a:latin typeface="Cambria Math" panose="02040503050406030204" pitchFamily="18" charset="0"/>
                                   </a:rPr>
-                                  <m:t>1</m:t>
-                                </m:r>
-                                <m:r>
-                                  <a:rPr sz="2000">
-                                    <a:latin typeface="Cambria Math" panose="02040503050406030204" pitchFamily="18" charset="0"/>
-                                  </a:rPr>
-                                  <m:t>,</m:t>
+                                  <m:t>1,</m:t>
                                 </m:r>
                                 <m:sSub>
                                   <m:sSubPr>
                                     <m:ctrlPr>
-                                      <a:rPr sz="2000" i="1">
+                                      <a:rPr sz="2000">
                                         <a:latin typeface="Cambria Math" panose="02040503050406030204" pitchFamily="18" charset="0"/>
                                       </a:rPr>
                                     </m:ctrlPr>
@@ -10381,7 +9963,7 @@
                                 <m:sSub>
                                   <m:sSubPr>
                                     <m:ctrlPr>
-                                      <a:rPr sz="2000" i="1">
+                                      <a:rPr sz="2000">
                                         <a:latin typeface="Cambria Math" panose="02040503050406030204" pitchFamily="18" charset="0"/>
                                       </a:rPr>
                                     </m:ctrlPr>
@@ -10410,7 +9992,7 @@
                                 <m:sSub>
                                   <m:sSubPr>
                                     <m:ctrlPr>
-                                      <a:rPr sz="2000" i="1">
+                                      <a:rPr sz="2000">
                                         <a:latin typeface="Cambria Math" panose="02040503050406030204" pitchFamily="18" charset="0"/>
                                       </a:rPr>
                                     </m:ctrlPr>
@@ -10475,7 +10057,7 @@
                                 <m:sSub>
                                   <m:sSubPr>
                                     <m:ctrlPr>
-                                      <a:rPr sz="2000" i="1">
+                                      <a:rPr sz="2000">
                                         <a:latin typeface="Cambria Math" panose="02040503050406030204" pitchFamily="18" charset="0"/>
                                       </a:rPr>
                                     </m:ctrlPr>
@@ -10504,7 +10086,7 @@
                                 <m:sSub>
                                   <m:sSubPr>
                                     <m:ctrlPr>
-                                      <a:rPr sz="2000" i="1">
+                                      <a:rPr sz="2000">
                                         <a:latin typeface="Cambria Math" panose="02040503050406030204" pitchFamily="18" charset="0"/>
                                       </a:rPr>
                                     </m:ctrlPr>
@@ -10533,7 +10115,7 @@
                                 <m:sSub>
                                   <m:sSubPr>
                                     <m:ctrlPr>
-                                      <a:rPr sz="2000" i="1">
+                                      <a:rPr sz="2000">
                                         <a:latin typeface="Cambria Math" panose="02040503050406030204" pitchFamily="18" charset="0"/>
                                       </a:rPr>
                                     </m:ctrlPr>
@@ -10572,7 +10154,7 @@
                                 <m:sSub>
                                   <m:sSubPr>
                                     <m:ctrlPr>
-                                      <a:rPr sz="2000" i="1">
+                                      <a:rPr sz="2000">
                                         <a:latin typeface="Cambria Math" panose="02040503050406030204" pitchFamily="18" charset="0"/>
                                       </a:rPr>
                                     </m:ctrlPr>
@@ -10622,11 +10204,11 @@
                     <m:oMathParaPr>
                       <m:jc m:val="center"/>
                     </m:oMathParaPr>
-                    <m:oMath xmlns:m="http://schemas.openxmlformats.org/officeDocument/2006/math">
+                    <m:oMath>
                       <m:sSub>
                         <m:sSubPr>
                           <m:ctrlPr>
-                            <a:rPr sz="2000" i="1">
+                            <a:rPr sz="2000">
                               <a:latin typeface="Cambria Math" panose="02040503050406030204" pitchFamily="18" charset="0"/>
                             </a:rPr>
                           </m:ctrlPr>
@@ -10657,7 +10239,7 @@
                       <m:sSub>
                         <m:sSubPr>
                           <m:ctrlPr>
-                            <a:rPr sz="2000" i="1">
+                            <a:rPr sz="2000">
                               <a:latin typeface="Cambria Math" panose="02040503050406030204" pitchFamily="18" charset="0"/>
                             </a:rPr>
                           </m:ctrlPr>
@@ -10688,7 +10270,7 @@
                       <m:sSub>
                         <m:sSubPr>
                           <m:ctrlPr>
-                            <a:rPr sz="2000" i="1">
+                            <a:rPr sz="2000">
                               <a:latin typeface="Cambria Math" panose="02040503050406030204" pitchFamily="18" charset="0"/>
                             </a:rPr>
                           </m:ctrlPr>
@@ -10713,7 +10295,7 @@
                       <m:sSub>
                         <m:sSubPr>
                           <m:ctrlPr>
-                            <a:rPr sz="2000" i="1">
+                            <a:rPr sz="2000">
                               <a:latin typeface="Cambria Math" panose="02040503050406030204" pitchFamily="18" charset="0"/>
                             </a:rPr>
                           </m:ctrlPr>
@@ -10744,7 +10326,7 @@
                       <m:sSub>
                         <m:sSubPr>
                           <m:ctrlPr>
-                            <a:rPr sz="2000" i="1">
+                            <a:rPr sz="2000">
                               <a:latin typeface="Cambria Math" panose="02040503050406030204" pitchFamily="18" charset="0"/>
                             </a:rPr>
                           </m:ctrlPr>
@@ -10789,12 +10371,12 @@
                     <m:oMathParaPr>
                       <m:jc m:val="center"/>
                     </m:oMathParaPr>
-                    <m:oMath xmlns:m="http://schemas.openxmlformats.org/officeDocument/2006/math">
+                    <m:oMath>
                       <m:acc>
                         <m:accPr>
                           <m:chr m:val="̂"/>
                           <m:ctrlPr>
-                            <a:rPr sz="2000" i="1">
+                            <a:rPr sz="2000">
                               <a:latin typeface="Cambria Math" panose="02040503050406030204" pitchFamily="18" charset="0"/>
                             </a:rPr>
                           </m:ctrlPr>
@@ -10824,7 +10406,7 @@
                         <m:accPr>
                           <m:chr m:val="⃗"/>
                           <m:ctrlPr>
-                            <a:rPr sz="2000" i="1">
+                            <a:rPr sz="2000">
                               <a:latin typeface="Cambria Math" panose="02040503050406030204" pitchFamily="18" charset="0"/>
                             </a:rPr>
                           </m:ctrlPr>
@@ -10848,7 +10430,7 @@
                         <m:accPr>
                           <m:chr m:val="⃗"/>
                           <m:ctrlPr>
-                            <a:rPr sz="2000" i="1">
+                            <a:rPr sz="2000">
                               <a:latin typeface="Cambria Math" panose="02040503050406030204" pitchFamily="18" charset="0"/>
                             </a:rPr>
                           </m:ctrlPr>
@@ -11567,7 +11149,7 @@
                       <m:accPr>
                         <m:chr m:val="⃗"/>
                         <m:ctrlPr>
-                          <a:rPr i="1">
+                          <a:rPr>
                             <a:latin typeface="Cambria Math" panose="02040503050406030204" pitchFamily="18" charset="0"/>
                           </a:rPr>
                         </m:ctrlPr>
@@ -11602,7 +11184,7 @@
                         <m:chr m:val="∑"/>
                         <m:limLoc m:val="undOvr"/>
                         <m:ctrlPr>
-                          <a:rPr lang="ar-AE" i="1">
+                          <a:rPr lang="ar-AE">
                             <a:latin typeface="Cambria Math" panose="02040503050406030204" pitchFamily="18" charset="0"/>
                           </a:rPr>
                         </m:ctrlPr>
@@ -11627,7 +11209,7 @@
                         <m:sSubSup>
                           <m:sSubSupPr>
                             <m:ctrlPr>
-                              <a:rPr lang="ar-AE" i="1">
+                              <a:rPr lang="ar-AE">
                                 <a:latin typeface="Cambria Math" panose="02040503050406030204" pitchFamily="18" charset="0"/>
                               </a:rPr>
                             </m:ctrlPr>
@@ -11699,7 +11281,7 @@
                           <m:accPr>
                             <m:chr m:val="̂"/>
                             <m:ctrlPr>
-                              <a:rPr i="1">
+                              <a:rPr>
                                 <a:latin typeface="Cambria Math" panose="02040503050406030204" pitchFamily="18" charset="0"/>
                               </a:rPr>
                             </m:ctrlPr>
@@ -11734,7 +11316,7 @@
                     <m:sSub>
                       <m:sSubPr>
                         <m:ctrlPr>
-                          <a:rPr i="1">
+                          <a:rPr>
                             <a:latin typeface="Cambria Math" panose="02040503050406030204" pitchFamily="18" charset="0"/>
                           </a:rPr>
                         </m:ctrlPr>
@@ -11772,11 +11354,11 @@
                     <m:oMathParaPr>
                       <m:jc m:val="center"/>
                     </m:oMathParaPr>
-                    <m:oMath xmlns:m="http://schemas.openxmlformats.org/officeDocument/2006/math">
+                    <m:oMath>
                       <m:limLow>
                         <m:limLowPr>
                           <m:ctrlPr>
-                            <a:rPr i="1">
+                            <a:rPr>
                               <a:latin typeface="Cambria Math" panose="02040503050406030204" pitchFamily="18" charset="0"/>
                             </a:rPr>
                           </m:ctrlPr>
@@ -11797,7 +11379,7 @@
                             <m:accPr>
                               <m:chr m:val="⃗"/>
                               <m:ctrlPr>
-                                <a:rPr i="1">
+                                <a:rPr>
                                   <a:latin typeface="Cambria Math" panose="02040503050406030204" pitchFamily="18" charset="0"/>
                                 </a:rPr>
                               </m:ctrlPr>
@@ -11818,7 +11400,7 @@
                           <m:chr m:val="∑"/>
                           <m:limLoc m:val="undOvr"/>
                           <m:ctrlPr>
-                            <a:rPr i="1">
+                            <a:rPr>
                               <a:latin typeface="Cambria Math" panose="02040503050406030204" pitchFamily="18" charset="0"/>
                             </a:rPr>
                           </m:ctrlPr>
@@ -11861,7 +11443,7 @@
                                   <m:sSub>
                                     <m:sSubPr>
                                       <m:ctrlPr>
-                                        <a:rPr i="1">
+                                        <a:rPr>
                                           <a:latin typeface="Cambria Math" panose="02040503050406030204" pitchFamily="18" charset="0"/>
                                         </a:rPr>
                                       </m:ctrlPr>
@@ -11892,7 +11474,7 @@
                                   <m:sSub>
                                     <m:sSubPr>
                                       <m:ctrlPr>
-                                        <a:rPr i="1">
+                                        <a:rPr>
                                           <a:latin typeface="Cambria Math" panose="02040503050406030204" pitchFamily="18" charset="0"/>
                                         </a:rPr>
                                       </m:ctrlPr>
@@ -11924,7 +11506,7 @@
                                     <m:accPr>
                                       <m:chr m:val="̂"/>
                                       <m:ctrlPr>
-                                        <a:rPr i="1">
+                                        <a:rPr>
                                           <a:latin typeface="Cambria Math" panose="02040503050406030204" pitchFamily="18" charset="0"/>
                                         </a:rPr>
                                       </m:ctrlPr>
@@ -11961,7 +11543,7 @@
                       <m:limLow>
                         <m:limLowPr>
                           <m:ctrlPr>
-                            <a:rPr i="1">
+                            <a:rPr>
                               <a:latin typeface="Cambria Math" panose="02040503050406030204" pitchFamily="18" charset="0"/>
                             </a:rPr>
                           </m:ctrlPr>
@@ -11982,7 +11564,7 @@
                             <m:accPr>
                               <m:chr m:val="⃗"/>
                               <m:ctrlPr>
-                                <a:rPr i="1">
+                                <a:rPr>
                                   <a:latin typeface="Cambria Math" panose="02040503050406030204" pitchFamily="18" charset="0"/>
                                 </a:rPr>
                               </m:ctrlPr>
@@ -12003,7 +11585,7 @@
                           <m:chr m:val="∑"/>
                           <m:limLoc m:val="undOvr"/>
                           <m:ctrlPr>
-                            <a:rPr i="1">
+                            <a:rPr>
                               <a:latin typeface="Cambria Math" panose="02040503050406030204" pitchFamily="18" charset="0"/>
                             </a:rPr>
                           </m:ctrlPr>
@@ -12046,7 +11628,7 @@
                                   <m:sSub>
                                     <m:sSubPr>
                                       <m:ctrlPr>
-                                        <a:rPr i="1">
+                                        <a:rPr>
                                           <a:latin typeface="Cambria Math" panose="02040503050406030204" pitchFamily="18" charset="0"/>
                                         </a:rPr>
                                       </m:ctrlPr>
@@ -12087,7 +11669,7 @@
                                       <m:sSub>
                                         <m:sSubPr>
                                           <m:ctrlPr>
-                                            <a:rPr i="1">
+                                            <a:rPr>
                                               <a:latin typeface="Cambria Math" panose="02040503050406030204" pitchFamily="18" charset="0"/>
                                             </a:rPr>
                                           </m:ctrlPr>
@@ -12134,7 +11716,7 @@
                       <m:limLow>
                         <m:limLowPr>
                           <m:ctrlPr>
-                            <a:rPr i="1">
+                            <a:rPr>
                               <a:latin typeface="Cambria Math" panose="02040503050406030204" pitchFamily="18" charset="0"/>
                             </a:rPr>
                           </m:ctrlPr>
@@ -12155,7 +11737,7 @@
                             <m:accPr>
                               <m:chr m:val="⃗"/>
                               <m:ctrlPr>
-                                <a:rPr i="1">
+                                <a:rPr>
                                   <a:latin typeface="Cambria Math" panose="02040503050406030204" pitchFamily="18" charset="0"/>
                                 </a:rPr>
                               </m:ctrlPr>
@@ -12176,7 +11758,7 @@
                           <m:chr m:val="∑"/>
                           <m:limLoc m:val="undOvr"/>
                           <m:ctrlPr>
-                            <a:rPr i="1">
+                            <a:rPr>
                               <a:latin typeface="Cambria Math" panose="02040503050406030204" pitchFamily="18" charset="0"/>
                             </a:rPr>
                           </m:ctrlPr>
@@ -12201,7 +11783,7 @@
                           <m:sSubSup>
                             <m:sSubSupPr>
                               <m:ctrlPr>
-                                <a:rPr i="1">
+                                <a:rPr>
                                   <a:latin typeface="Cambria Math" panose="02040503050406030204" pitchFamily="18" charset="0"/>
                                 </a:rPr>
                               </m:ctrlPr>
@@ -12251,7 +11833,7 @@
                     <m:sSub>
                       <m:sSubPr>
                         <m:ctrlPr>
-                          <a:rPr i="1">
+                          <a:rPr>
                             <a:latin typeface="Cambria Math" panose="02040503050406030204" pitchFamily="18" charset="0"/>
                           </a:rPr>
                         </m:ctrlPr>
@@ -12666,12 +12248,12 @@
                     <m:oMathParaPr>
                       <m:jc m:val="center"/>
                     </m:oMathParaPr>
-                    <m:oMath xmlns:m="http://schemas.openxmlformats.org/officeDocument/2006/math">
+                    <m:oMath>
                       <m:acc>
                         <m:accPr>
                           <m:chr m:val="⃗"/>
                           <m:ctrlPr>
-                            <a:rPr i="1">
+                            <a:rPr>
                               <a:latin typeface="Cambria Math" panose="02040503050406030204" pitchFamily="18" charset="0"/>
                             </a:rPr>
                           </m:ctrlPr>
@@ -12694,7 +12276,7 @@
                       <m:sSup>
                         <m:sSupPr>
                           <m:ctrlPr>
-                            <a:rPr i="1">
+                            <a:rPr>
                               <a:latin typeface="Cambria Math" panose="02040503050406030204" pitchFamily="18" charset="0"/>
                             </a:rPr>
                           </m:ctrlPr>
@@ -12712,13 +12294,7 @@
                             <a:rPr>
                               <a:latin typeface="Cambria Math" panose="02040503050406030204" pitchFamily="18" charset="0"/>
                             </a:rPr>
-                            <m:t>−</m:t>
-                          </m:r>
-                          <m:r>
-                            <a:rPr>
-                              <a:latin typeface="Cambria Math" panose="02040503050406030204" pitchFamily="18" charset="0"/>
-                            </a:rPr>
-                            <m:t>1</m:t>
+                            <m:t>−1</m:t>
                           </m:r>
                         </m:sup>
                       </m:sSup>
@@ -12746,7 +12322,7 @@
                     <m:sSup>
                       <m:sSupPr>
                         <m:ctrlPr>
-                          <a:rPr i="1">
+                          <a:rPr>
                             <a:latin typeface="Cambria Math" panose="02040503050406030204" pitchFamily="18" charset="0"/>
                           </a:rPr>
                         </m:ctrlPr>
@@ -12764,13 +12340,7 @@
                           <a:rPr>
                             <a:latin typeface="Cambria Math" panose="02040503050406030204" pitchFamily="18" charset="0"/>
                           </a:rPr>
-                          <m:t>−</m:t>
-                        </m:r>
-                        <m:r>
-                          <a:rPr>
-                            <a:latin typeface="Cambria Math" panose="02040503050406030204" pitchFamily="18" charset="0"/>
-                          </a:rPr>
-                          <m:t>1</m:t>
+                          <m:t>−1</m:t>
                         </m:r>
                       </m:sup>
                     </m:sSup>
@@ -12834,7 +12404,7 @@
                         <m:sSup>
                           <m:sSupPr>
                             <m:ctrlPr>
-                              <a:rPr i="1">
+                              <a:rPr>
                                 <a:latin typeface="Cambria Math" panose="02040503050406030204" pitchFamily="18" charset="0"/>
                               </a:rPr>
                             </m:ctrlPr>
@@ -13338,7 +12908,7 @@
                     <m:oMathParaPr>
                       <m:jc m:val="center"/>
                     </m:oMathParaPr>
-                    <m:oMath xmlns:m="http://schemas.openxmlformats.org/officeDocument/2006/math">
+                    <m:oMath>
                       <m:r>
                         <a:rPr lang="en-US">
                           <a:latin typeface="Cambria Math" panose="02040503050406030204" pitchFamily="18" charset="0"/>
@@ -13349,7 +12919,7 @@
                         <m:accPr>
                           <m:chr m:val="⃗"/>
                           <m:ctrlPr>
-                            <a:rPr lang="ar-AE" i="1">
+                            <a:rPr lang="ar-AE">
                               <a:latin typeface="Cambria Math" panose="02040503050406030204" pitchFamily="18" charset="0"/>
                             </a:rPr>
                           </m:ctrlPr>
@@ -13388,7 +12958,7 @@
                         <m:accPr>
                           <m:chr m:val="⃗"/>
                           <m:ctrlPr>
-                            <a:rPr lang="ar-AE" i="1">
+                            <a:rPr lang="ar-AE">
                               <a:latin typeface="Cambria Math" panose="02040503050406030204" pitchFamily="18" charset="0"/>
                             </a:rPr>
                           </m:ctrlPr>
@@ -13412,19 +12982,7 @@
                         <a:rPr lang="en-US" b="0" i="1" smtClean="0">
                           <a:latin typeface="Cambria Math" panose="02040503050406030204" pitchFamily="18" charset="0"/>
                         </a:rPr>
-                        <m:t>𝑤</m:t>
-                      </m:r>
-                      <m:r>
-                        <a:rPr lang="en-US" b="0" i="1" smtClean="0">
-                          <a:latin typeface="Cambria Math" panose="02040503050406030204" pitchFamily="18" charset="0"/>
-                        </a:rPr>
-                        <m:t>h</m:t>
-                      </m:r>
-                      <m:r>
-                        <a:rPr lang="en-US" b="0" i="1" smtClean="0">
-                          <a:latin typeface="Cambria Math" panose="02040503050406030204" pitchFamily="18" charset="0"/>
-                        </a:rPr>
-                        <m:t>𝑒𝑟𝑒</m:t>
+                        <m:t>𝑤ℎ𝑒𝑟𝑒</m:t>
                       </m:r>
                       <m:r>
                         <a:rPr lang="en-US" b="0" i="1" smtClean="0">
@@ -13441,7 +12999,7 @@
                       <m:d>
                         <m:dPr>
                           <m:ctrlPr>
-                            <a:rPr lang="en-US" b="0" i="1" smtClean="0">
+                            <a:rPr lang="ar-AE" i="1">
                               <a:latin typeface="Cambria Math" panose="02040503050406030204" pitchFamily="18" charset="0"/>
                             </a:rPr>
                           </m:ctrlPr>
@@ -13451,7 +13009,7 @@
                             <m:accPr>
                               <m:chr m:val="⃗"/>
                               <m:ctrlPr>
-                                <a:rPr lang="ar-AE" i="1">
+                                <a:rPr lang="ar-AE">
                                   <a:latin typeface="Cambria Math" panose="02040503050406030204" pitchFamily="18" charset="0"/>
                                 </a:rPr>
                               </m:ctrlPr>
@@ -13495,7 +13053,7 @@
                     <m:sSup>
                       <m:sSupPr>
                         <m:ctrlPr>
-                          <a:rPr lang="ar-AE" i="1">
+                          <a:rPr lang="ar-AE">
                             <a:latin typeface="Cambria Math" panose="02040503050406030204" pitchFamily="18" charset="0"/>
                           </a:rPr>
                         </m:ctrlPr>
@@ -13533,7 +13091,7 @@
                       <m:accPr>
                         <m:chr m:val="⃗"/>
                         <m:ctrlPr>
-                          <a:rPr lang="ar-AE" i="1">
+                          <a:rPr lang="ar-AE">
                             <a:latin typeface="Cambria Math" panose="02040503050406030204" pitchFamily="18" charset="0"/>
                           </a:rPr>
                         </m:ctrlPr>
@@ -13551,13 +13109,7 @@
                       <a:rPr lang="ar-AE">
                         <a:latin typeface="Cambria Math" panose="02040503050406030204" pitchFamily="18" charset="0"/>
                       </a:rPr>
-                      <m:t>=</m:t>
-                    </m:r>
-                    <m:r>
-                      <a:rPr lang="ar-AE">
-                        <a:latin typeface="Cambria Math" panose="02040503050406030204" pitchFamily="18" charset="0"/>
-                      </a:rPr>
-                      <m:t>0</m:t>
+                      <m:t>=0</m:t>
                     </m:r>
                   </m:oMath>
                 </a14:m>
@@ -13572,11 +13124,11 @@
                     <m:oMathParaPr>
                       <m:jc m:val="center"/>
                     </m:oMathParaPr>
-                    <m:oMath xmlns:m="http://schemas.openxmlformats.org/officeDocument/2006/math">
+                    <m:oMath>
                       <m:sSup>
                         <m:sSupPr>
                           <m:ctrlPr>
-                            <a:rPr lang="ar-AE" i="1">
+                            <a:rPr lang="ar-AE">
                               <a:latin typeface="Cambria Math" panose="02040503050406030204" pitchFamily="18" charset="0"/>
                             </a:rPr>
                           </m:ctrlPr>
@@ -13608,7 +13160,7 @@
                         <m:accPr>
                           <m:chr m:val="⃗"/>
                           <m:ctrlPr>
-                            <a:rPr lang="ar-AE" i="1">
+                            <a:rPr lang="ar-AE">
                               <a:latin typeface="Cambria Math" panose="02040503050406030204" pitchFamily="18" charset="0"/>
                             </a:rPr>
                           </m:ctrlPr>
@@ -13631,7 +13183,7 @@
                       <m:sSup>
                         <m:sSupPr>
                           <m:ctrlPr>
-                            <a:rPr lang="ar-AE" i="1">
+                            <a:rPr lang="ar-AE">
                               <a:latin typeface="Cambria Math" panose="02040503050406030204" pitchFamily="18" charset="0"/>
                             </a:rPr>
                           </m:ctrlPr>
@@ -13657,7 +13209,7 @@
                         <m:accPr>
                           <m:chr m:val="̂"/>
                           <m:ctrlPr>
-                            <a:rPr lang="ar-AE" i="1">
+                            <a:rPr lang="ar-AE">
                               <a:latin typeface="Cambria Math" panose="02040503050406030204" pitchFamily="18" charset="0"/>
                             </a:rPr>
                           </m:ctrlPr>
@@ -13687,7 +13239,7 @@
                     <m:sSup>
                       <m:sSupPr>
                         <m:ctrlPr>
-                          <a:rPr lang="ar-AE" i="1">
+                          <a:rPr lang="ar-AE">
                             <a:latin typeface="Cambria Math" panose="02040503050406030204" pitchFamily="18" charset="0"/>
                           </a:rPr>
                         </m:ctrlPr>
@@ -13735,12 +13287,12 @@
                     <m:oMathParaPr>
                       <m:jc m:val="center"/>
                     </m:oMathParaPr>
-                    <m:oMath xmlns:m="http://schemas.openxmlformats.org/officeDocument/2006/math">
+                    <m:oMath>
                       <m:acc>
                         <m:accPr>
                           <m:chr m:val="⃗"/>
                           <m:ctrlPr>
-                            <a:rPr lang="ar-AE" i="1">
+                            <a:rPr lang="ar-AE">
                               <a:latin typeface="Cambria Math" panose="02040503050406030204" pitchFamily="18" charset="0"/>
                             </a:rPr>
                           </m:ctrlPr>
@@ -13781,7 +13333,7 @@
                               <m:sSup>
                                 <m:sSupPr>
                                   <m:ctrlPr>
-                                    <a:rPr lang="ar-AE" i="1">
+                                    <a:rPr lang="ar-AE">
                                       <a:latin typeface="Cambria Math" panose="02040503050406030204" pitchFamily="18" charset="0"/>
                                     </a:rPr>
                                   </m:ctrlPr>
@@ -13817,20 +13369,14 @@
                             <a:rPr lang="ar-AE">
                               <a:latin typeface="Cambria Math" panose="02040503050406030204" pitchFamily="18" charset="0"/>
                             </a:rPr>
-                            <m:t>−</m:t>
-                          </m:r>
-                          <m:r>
-                            <a:rPr lang="ar-AE">
-                              <a:latin typeface="Cambria Math" panose="02040503050406030204" pitchFamily="18" charset="0"/>
-                            </a:rPr>
-                            <m:t>1</m:t>
+                            <m:t>−1</m:t>
                           </m:r>
                         </m:sup>
                       </m:sSup>
                       <m:sSup>
                         <m:sSupPr>
                           <m:ctrlPr>
-                            <a:rPr lang="ar-AE" i="1">
+                            <a:rPr lang="ar-AE">
                               <a:latin typeface="Cambria Math" panose="02040503050406030204" pitchFamily="18" charset="0"/>
                             </a:rPr>
                           </m:ctrlPr>
@@ -13856,7 +13402,7 @@
                         <m:accPr>
                           <m:chr m:val="̂"/>
                           <m:ctrlPr>
-                            <a:rPr lang="ar-AE" i="1">
+                            <a:rPr lang="ar-AE">
                               <a:latin typeface="Cambria Math" panose="02040503050406030204" pitchFamily="18" charset="0"/>
                             </a:rPr>
                           </m:ctrlPr>
@@ -14271,12 +13817,12 @@
                     <m:oMathParaPr>
                       <m:jc m:val="center"/>
                     </m:oMathParaPr>
-                    <m:oMath xmlns:m="http://schemas.openxmlformats.org/officeDocument/2006/math">
+                    <m:oMath>
                       <m:acc>
                         <m:accPr>
                           <m:chr m:val="⃗"/>
                           <m:ctrlPr>
-                            <a:rPr i="1">
+                            <a:rPr>
                               <a:latin typeface="Cambria Math" panose="02040503050406030204" pitchFamily="18" charset="0"/>
                             </a:rPr>
                           </m:ctrlPr>
@@ -14317,7 +13863,7 @@
                               <m:sSup>
                                 <m:sSupPr>
                                   <m:ctrlPr>
-                                    <a:rPr i="1">
+                                    <a:rPr>
                                       <a:latin typeface="Cambria Math" panose="02040503050406030204" pitchFamily="18" charset="0"/>
                                     </a:rPr>
                                   </m:ctrlPr>
@@ -14353,20 +13899,14 @@
                             <a:rPr>
                               <a:latin typeface="Cambria Math" panose="02040503050406030204" pitchFamily="18" charset="0"/>
                             </a:rPr>
-                            <m:t>−</m:t>
-                          </m:r>
-                          <m:r>
-                            <a:rPr>
-                              <a:latin typeface="Cambria Math" panose="02040503050406030204" pitchFamily="18" charset="0"/>
-                            </a:rPr>
-                            <m:t>1</m:t>
+                            <m:t>−1</m:t>
                           </m:r>
                         </m:sup>
                       </m:sSup>
                       <m:sSup>
                         <m:sSupPr>
                           <m:ctrlPr>
-                            <a:rPr i="1">
+                            <a:rPr>
                               <a:latin typeface="Cambria Math" panose="02040503050406030204" pitchFamily="18" charset="0"/>
                             </a:rPr>
                           </m:ctrlPr>
@@ -14392,7 +13932,7 @@
                         <m:accPr>
                           <m:chr m:val="̂"/>
                           <m:ctrlPr>
-                            <a:rPr i="1">
+                            <a:rPr>
                               <a:latin typeface="Cambria Math" panose="02040503050406030204" pitchFamily="18" charset="0"/>
                             </a:rPr>
                           </m:ctrlPr>
@@ -14418,7 +13958,7 @@
                     <m:f>
                       <m:fPr>
                         <m:ctrlPr>
-                          <a:rPr i="1">
+                          <a:rPr>
                             <a:latin typeface="Cambria Math" panose="02040503050406030204" pitchFamily="18" charset="0"/>
                           </a:rPr>
                         </m:ctrlPr>
@@ -14443,7 +13983,7 @@
                     <m:sSup>
                       <m:sSupPr>
                         <m:ctrlPr>
-                          <a:rPr i="1">
+                          <a:rPr>
                             <a:latin typeface="Cambria Math" panose="02040503050406030204" pitchFamily="18" charset="0"/>
                           </a:rPr>
                         </m:ctrlPr>
@@ -14563,25 +14103,7 @@
                       <a:rPr>
                         <a:latin typeface="Cambria Math" panose="02040503050406030204" pitchFamily="18" charset="0"/>
                       </a:rPr>
-                      <m:t>&gt;</m:t>
-                    </m:r>
-                    <m:r>
-                      <a:rPr>
-                        <a:latin typeface="Cambria Math" panose="02040503050406030204" pitchFamily="18" charset="0"/>
-                      </a:rPr>
-                      <m:t>1</m:t>
-                    </m:r>
-                    <m:r>
-                      <a:rPr>
-                        <a:latin typeface="Cambria Math" panose="02040503050406030204" pitchFamily="18" charset="0"/>
-                      </a:rPr>
-                      <m:t>,</m:t>
-                    </m:r>
-                    <m:r>
-                      <a:rPr>
-                        <a:latin typeface="Cambria Math" panose="02040503050406030204" pitchFamily="18" charset="0"/>
-                      </a:rPr>
-                      <m:t>000</m:t>
+                      <m:t>&gt;1,000</m:t>
                     </m:r>
                   </m:oMath>
                 </a14:m>
@@ -14958,7 +14480,7 @@
                       <m:accPr>
                         <m:chr m:val="⃗"/>
                         <m:ctrlPr>
-                          <a:rPr lang="ar-AE" sz="1600" i="1">
+                          <a:rPr lang="ar-AE" sz="1600">
                             <a:latin typeface="Cambria Math" panose="02040503050406030204" pitchFamily="18" charset="0"/>
                           </a:rPr>
                         </m:ctrlPr>
@@ -15015,7 +14537,7 @@
                           <m:accPr>
                             <m:chr m:val="⃗"/>
                             <m:ctrlPr>
-                              <a:rPr lang="ar-AE" sz="1600" i="1">
+                              <a:rPr lang="ar-AE" sz="1600">
                                 <a:latin typeface="Cambria Math" panose="02040503050406030204" pitchFamily="18" charset="0"/>
                               </a:rPr>
                             </m:ctrlPr>
@@ -15072,7 +14594,7 @@
                     <m:sSub>
                       <m:sSubPr>
                         <m:ctrlPr>
-                          <a:rPr lang="ar-AE" sz="1600" i="1">
+                          <a:rPr lang="ar-AE" sz="1600">
                             <a:latin typeface="Cambria Math" panose="02040503050406030204" pitchFamily="18" charset="0"/>
                           </a:rPr>
                         </m:ctrlPr>
@@ -15110,7 +14632,7 @@
                     <m:oMathParaPr>
                       <m:jc m:val="center"/>
                     </m:oMathParaPr>
-                    <m:oMath xmlns:m="http://schemas.openxmlformats.org/officeDocument/2006/math">
+                    <m:oMath>
                       <m:r>
                         <a:rPr lang="ar-AE" sz="1600">
                           <a:latin typeface="Cambria Math" panose="02040503050406030204" pitchFamily="18" charset="0"/>
@@ -15130,7 +14652,7 @@
                             <m:accPr>
                               <m:chr m:val="⃗"/>
                               <m:ctrlPr>
-                                <a:rPr lang="ar-AE" sz="1600" i="1">
+                                <a:rPr lang="ar-AE" sz="1600">
                                   <a:latin typeface="Cambria Math" panose="02040503050406030204" pitchFamily="18" charset="0"/>
                                 </a:rPr>
                               </m:ctrlPr>
@@ -15153,7 +14675,7 @@
                           <m:sSup>
                             <m:sSupPr>
                               <m:ctrlPr>
-                                <a:rPr lang="ar-AE" sz="1600" i="1">
+                                <a:rPr lang="ar-AE" sz="1600">
                                   <a:latin typeface="Cambria Math" panose="02040503050406030204" pitchFamily="18" charset="0"/>
                                 </a:rPr>
                               </m:ctrlPr>
@@ -15188,7 +14710,7 @@
                           <m:chr m:val="∏"/>
                           <m:limLoc m:val="undOvr"/>
                           <m:ctrlPr>
-                            <a:rPr lang="ar-AE" sz="1600" i="1">
+                            <a:rPr lang="ar-AE" sz="1600">
                               <a:latin typeface="Cambria Math" panose="02040503050406030204" pitchFamily="18" charset="0"/>
                             </a:rPr>
                           </m:ctrlPr>
@@ -15204,13 +14726,7 @@
                             <a:rPr lang="ar-AE" sz="1600">
                               <a:latin typeface="Cambria Math" panose="02040503050406030204" pitchFamily="18" charset="0"/>
                             </a:rPr>
-                            <m:t>=</m:t>
-                          </m:r>
-                          <m:r>
-                            <a:rPr lang="ar-AE" sz="1600">
-                              <a:latin typeface="Cambria Math" panose="02040503050406030204" pitchFamily="18" charset="0"/>
-                            </a:rPr>
-                            <m:t>1</m:t>
+                            <m:t>=1</m:t>
                           </m:r>
                         </m:sub>
                         <m:sup>
@@ -15225,7 +14741,7 @@
                           <m:f>
                             <m:fPr>
                               <m:ctrlPr>
-                                <a:rPr lang="ar-AE" sz="1600" i="1">
+                                <a:rPr lang="ar-AE" sz="1600">
                                   <a:latin typeface="Cambria Math" panose="02040503050406030204" pitchFamily="18" charset="0"/>
                                 </a:rPr>
                               </m:ctrlPr>
@@ -15251,7 +14767,7 @@
                                   <m:d>
                                     <m:dPr>
                                       <m:ctrlPr>
-                                        <a:rPr lang="ar-AE" sz="1600" i="1">
+                                        <a:rPr lang="ar-AE" sz="1600">
                                           <a:latin typeface="Cambria Math" panose="02040503050406030204" pitchFamily="18" charset="0"/>
                                         </a:rPr>
                                       </m:ctrlPr>
@@ -15272,7 +14788,7 @@
                                       <m:sSup>
                                         <m:sSupPr>
                                           <m:ctrlPr>
-                                            <a:rPr lang="ar-AE" sz="1600" i="1">
+                                            <a:rPr lang="ar-AE" sz="1600">
                                               <a:latin typeface="Cambria Math" panose="02040503050406030204" pitchFamily="18" charset="0"/>
                                             </a:rPr>
                                           </m:ctrlPr>
@@ -15302,19 +14818,7 @@
                                     <a:rPr lang="ar-AE" sz="1600">
                                       <a:latin typeface="Cambria Math" panose="02040503050406030204" pitchFamily="18" charset="0"/>
                                     </a:rPr>
-                                    <m:t>1</m:t>
-                                  </m:r>
-                                  <m:r>
-                                    <a:rPr lang="ar-AE" sz="1600">
-                                      <a:latin typeface="Cambria Math" panose="02040503050406030204" pitchFamily="18" charset="0"/>
-                                    </a:rPr>
-                                    <m:t>/</m:t>
-                                  </m:r>
-                                  <m:r>
-                                    <a:rPr lang="ar-AE" sz="1600">
-                                      <a:latin typeface="Cambria Math" panose="02040503050406030204" pitchFamily="18" charset="0"/>
-                                    </a:rPr>
-                                    <m:t>2</m:t>
+                                    <m:t>1/2</m:t>
                                   </m:r>
                                 </m:sup>
                               </m:sSup>
@@ -15333,7 +14837,7 @@
                           <m:begChr m:val="{"/>
                           <m:endChr m:val="}"/>
                           <m:ctrlPr>
-                            <a:rPr lang="ar-AE" sz="1600" i="1">
+                            <a:rPr lang="ar-AE" sz="1600">
                               <a:latin typeface="Cambria Math" panose="02040503050406030204" pitchFamily="18" charset="0"/>
                             </a:rPr>
                           </m:ctrlPr>
@@ -15348,7 +14852,7 @@
                           <m:f>
                             <m:fPr>
                               <m:ctrlPr>
-                                <a:rPr lang="ar-AE" sz="1600" i="1">
+                                <a:rPr lang="ar-AE" sz="1600">
                                   <a:latin typeface="Cambria Math" panose="02040503050406030204" pitchFamily="18" charset="0"/>
                                 </a:rPr>
                               </m:ctrlPr>
@@ -15371,7 +14875,7 @@
                               <m:sSup>
                                 <m:sSupPr>
                                   <m:ctrlPr>
-                                    <a:rPr lang="ar-AE" sz="1600" i="1">
+                                    <a:rPr lang="ar-AE" sz="1600">
                                       <a:latin typeface="Cambria Math" panose="02040503050406030204" pitchFamily="18" charset="0"/>
                                     </a:rPr>
                                   </m:ctrlPr>
@@ -15404,7 +14908,7 @@
                           <m:sSub>
                             <m:sSubPr>
                               <m:ctrlPr>
-                                <a:rPr lang="ar-AE" sz="1600" i="1">
+                                <a:rPr lang="ar-AE" sz="1600">
                                   <a:latin typeface="Cambria Math" panose="02040503050406030204" pitchFamily="18" charset="0"/>
                                 </a:rPr>
                               </m:ctrlPr>
@@ -15435,7 +14939,7 @@
                           <m:sSubSup>
                             <m:sSubSupPr>
                               <m:ctrlPr>
-                                <a:rPr lang="ar-AE" sz="1600" i="1">
+                                <a:rPr lang="ar-AE" sz="1600">
                                   <a:latin typeface="Cambria Math" panose="02040503050406030204" pitchFamily="18" charset="0"/>
                                 </a:rPr>
                               </m:ctrlPr>
@@ -15469,7 +14973,7 @@
                             <m:accPr>
                               <m:chr m:val="⃗"/>
                               <m:ctrlPr>
-                                <a:rPr lang="ar-AE" sz="1600" i="1">
+                                <a:rPr lang="ar-AE" sz="1600">
                                   <a:latin typeface="Cambria Math" panose="02040503050406030204" pitchFamily="18" charset="0"/>
                                 </a:rPr>
                               </m:ctrlPr>
@@ -15486,7 +14990,7 @@
                           <m:sSup>
                             <m:sSupPr>
                               <m:ctrlPr>
-                                <a:rPr lang="ar-AE" sz="1600" i="1">
+                                <a:rPr lang="ar-AE" sz="1600">
                                   <a:latin typeface="Cambria Math" panose="02040503050406030204" pitchFamily="18" charset="0"/>
                                 </a:rPr>
                               </m:ctrlPr>
@@ -15531,7 +15035,7 @@
                     <m:oMathParaPr>
                       <m:jc m:val="center"/>
                     </m:oMathParaPr>
-                    <m:oMath xmlns:m="http://schemas.openxmlformats.org/officeDocument/2006/math">
+                    <m:oMath>
                       <m:r>
                         <a:rPr lang="en-US" sz="1600">
                           <a:latin typeface="Cambria Math" panose="02040503050406030204" pitchFamily="18" charset="0"/>
@@ -15551,7 +15055,7 @@
                             <m:accPr>
                               <m:chr m:val="⃗"/>
                               <m:ctrlPr>
-                                <a:rPr lang="ar-AE" sz="1600" i="1">
+                                <a:rPr lang="ar-AE" sz="1600">
                                   <a:latin typeface="Cambria Math" panose="02040503050406030204" pitchFamily="18" charset="0"/>
                                 </a:rPr>
                               </m:ctrlPr>
@@ -15574,7 +15078,7 @@
                           <m:sSup>
                             <m:sSupPr>
                               <m:ctrlPr>
-                                <a:rPr lang="ar-AE" sz="1600" i="1">
+                                <a:rPr lang="ar-AE" sz="1600">
                                   <a:latin typeface="Cambria Math" panose="02040503050406030204" pitchFamily="18" charset="0"/>
                                 </a:rPr>
                               </m:ctrlPr>
@@ -15607,7 +15111,7 @@
                       <m:f>
                         <m:fPr>
                           <m:ctrlPr>
-                            <a:rPr lang="ar-AE" sz="1600" i="1">
+                            <a:rPr lang="ar-AE" sz="1600">
                               <a:latin typeface="Cambria Math" panose="02040503050406030204" pitchFamily="18" charset="0"/>
                             </a:rPr>
                           </m:ctrlPr>
@@ -15634,7 +15138,7 @@
                           <m:begChr m:val="{"/>
                           <m:endChr m:val="}"/>
                           <m:ctrlPr>
-                            <a:rPr lang="ar-AE" sz="1600" i="1">
+                            <a:rPr lang="ar-AE" sz="1600">
                               <a:latin typeface="Cambria Math" panose="02040503050406030204" pitchFamily="18" charset="0"/>
                             </a:rPr>
                           </m:ctrlPr>
@@ -15670,7 +15174,7 @@
                               <m:sSup>
                                 <m:sSupPr>
                                   <m:ctrlPr>
-                                    <a:rPr lang="ar-AE" sz="1600" i="1">
+                                    <a:rPr lang="ar-AE" sz="1600">
                                       <a:latin typeface="Cambria Math" panose="02040503050406030204" pitchFamily="18" charset="0"/>
                                     </a:rPr>
                                   </m:ctrlPr>
@@ -15703,7 +15207,7 @@
                           <m:f>
                             <m:fPr>
                               <m:ctrlPr>
-                                <a:rPr lang="ar-AE" sz="1600" i="1">
+                                <a:rPr lang="ar-AE" sz="1600">
                                   <a:latin typeface="Cambria Math" panose="02040503050406030204" pitchFamily="18" charset="0"/>
                                 </a:rPr>
                               </m:ctrlPr>
@@ -15720,7 +15224,7 @@
                               <m:sSup>
                                 <m:sSupPr>
                                   <m:ctrlPr>
-                                    <a:rPr lang="ar-AE" sz="1600" i="1">
+                                    <a:rPr lang="ar-AE" sz="1600">
                                       <a:latin typeface="Cambria Math" panose="02040503050406030204" pitchFamily="18" charset="0"/>
                                     </a:rPr>
                                   </m:ctrlPr>
@@ -15749,7 +15253,7 @@
                               <m:chr m:val="∑"/>
                               <m:limLoc m:val="undOvr"/>
                               <m:ctrlPr>
-                                <a:rPr lang="ar-AE" sz="1600" i="1">
+                                <a:rPr lang="ar-AE" sz="1600">
                                   <a:latin typeface="Cambria Math" panose="02040503050406030204" pitchFamily="18" charset="0"/>
                                 </a:rPr>
                               </m:ctrlPr>
@@ -15765,13 +15269,7 @@
                                 <a:rPr lang="ar-AE" sz="1600">
                                   <a:latin typeface="Cambria Math" panose="02040503050406030204" pitchFamily="18" charset="0"/>
                                 </a:rPr>
-                                <m:t>=</m:t>
-                              </m:r>
-                              <m:r>
-                                <a:rPr lang="ar-AE" sz="1600">
-                                  <a:latin typeface="Cambria Math" panose="02040503050406030204" pitchFamily="18" charset="0"/>
-                                </a:rPr>
-                                <m:t>1</m:t>
+                                <m:t>=1</m:t>
                               </m:r>
                             </m:sub>
                             <m:sup>
@@ -15794,7 +15292,7 @@
                           <m:sSub>
                             <m:sSubPr>
                               <m:ctrlPr>
-                                <a:rPr lang="ar-AE" sz="1600" i="1">
+                                <a:rPr lang="ar-AE" sz="1600">
                                   <a:latin typeface="Cambria Math" panose="02040503050406030204" pitchFamily="18" charset="0"/>
                                 </a:rPr>
                               </m:ctrlPr>
@@ -15825,7 +15323,7 @@
                           <m:sSubSup>
                             <m:sSubSupPr>
                               <m:ctrlPr>
-                                <a:rPr lang="ar-AE" sz="1600" i="1">
+                                <a:rPr lang="ar-AE" sz="1600">
                                   <a:latin typeface="Cambria Math" panose="02040503050406030204" pitchFamily="18" charset="0"/>
                                 </a:rPr>
                               </m:ctrlPr>
@@ -15859,7 +15357,7 @@
                             <m:accPr>
                               <m:chr m:val="⃗"/>
                               <m:ctrlPr>
-                                <a:rPr lang="ar-AE" sz="1600" i="1">
+                                <a:rPr lang="ar-AE" sz="1600">
                                   <a:latin typeface="Cambria Math" panose="02040503050406030204" pitchFamily="18" charset="0"/>
                                 </a:rPr>
                               </m:ctrlPr>
@@ -15876,7 +15374,7 @@
                           <m:sSup>
                             <m:sSupPr>
                               <m:ctrlPr>
-                                <a:rPr lang="ar-AE" sz="1600" i="1">
+                                <a:rPr lang="ar-AE" sz="1600">
                                   <a:latin typeface="Cambria Math" panose="02040503050406030204" pitchFamily="18" charset="0"/>
                                 </a:rPr>
                               </m:ctrlPr>
@@ -15916,7 +15414,7 @@
                     <m:sSup>
                       <m:sSupPr>
                         <m:ctrlPr>
-                          <a:rPr lang="ar-AE" sz="1600" i="1">
+                          <a:rPr lang="ar-AE" sz="1600">
                             <a:latin typeface="Cambria Math" panose="02040503050406030204" pitchFamily="18" charset="0"/>
                           </a:rPr>
                         </m:ctrlPr>
@@ -15962,7 +15460,7 @@
                     <m:oMathParaPr>
                       <m:jc m:val="center"/>
                     </m:oMathParaPr>
-                    <m:oMath xmlns:m="http://schemas.openxmlformats.org/officeDocument/2006/math">
+                    <m:oMath>
                       <m:r>
                         <a:rPr lang="en-US" sz="1600">
                           <a:latin typeface="Cambria Math" panose="02040503050406030204" pitchFamily="18" charset="0"/>
@@ -15982,7 +15480,7 @@
                             <m:accPr>
                               <m:chr m:val="⃗"/>
                               <m:ctrlPr>
-                                <a:rPr lang="ar-AE" sz="1600" i="1">
+                                <a:rPr lang="ar-AE" sz="1600">
                                   <a:latin typeface="Cambria Math" panose="02040503050406030204" pitchFamily="18" charset="0"/>
                                 </a:rPr>
                               </m:ctrlPr>
@@ -16009,7 +15507,7 @@
                           <m:chr m:val="∑"/>
                           <m:limLoc m:val="undOvr"/>
                           <m:ctrlPr>
-                            <a:rPr lang="ar-AE" sz="1600" i="1">
+                            <a:rPr lang="ar-AE" sz="1600">
                               <a:latin typeface="Cambria Math" panose="02040503050406030204" pitchFamily="18" charset="0"/>
                             </a:rPr>
                           </m:ctrlPr>
@@ -16025,13 +15523,7 @@
                             <a:rPr lang="ar-AE" sz="1600">
                               <a:latin typeface="Cambria Math" panose="02040503050406030204" pitchFamily="18" charset="0"/>
                             </a:rPr>
-                            <m:t>=</m:t>
-                          </m:r>
-                          <m:r>
-                            <a:rPr lang="ar-AE" sz="1600">
-                              <a:latin typeface="Cambria Math" panose="02040503050406030204" pitchFamily="18" charset="0"/>
-                            </a:rPr>
-                            <m:t>1</m:t>
+                            <m:t>=1</m:t>
                           </m:r>
                         </m:sub>
                         <m:sup>
@@ -16054,7 +15546,7 @@
                       <m:sSub>
                         <m:sSubPr>
                           <m:ctrlPr>
-                            <a:rPr lang="ar-AE" sz="1600" i="1">
+                            <a:rPr lang="ar-AE" sz="1600">
                               <a:latin typeface="Cambria Math" panose="02040503050406030204" pitchFamily="18" charset="0"/>
                             </a:rPr>
                           </m:ctrlPr>
@@ -16085,7 +15577,7 @@
                       <m:sSubSup>
                         <m:sSubSupPr>
                           <m:ctrlPr>
-                            <a:rPr lang="ar-AE" sz="1600" i="1">
+                            <a:rPr lang="ar-AE" sz="1600">
                               <a:latin typeface="Cambria Math" panose="02040503050406030204" pitchFamily="18" charset="0"/>
                             </a:rPr>
                           </m:ctrlPr>
@@ -16119,7 +15611,7 @@
                         <m:accPr>
                           <m:chr m:val="⃗"/>
                           <m:ctrlPr>
-                            <a:rPr lang="ar-AE" sz="1600" i="1">
+                            <a:rPr lang="ar-AE" sz="1600">
                               <a:latin typeface="Cambria Math" panose="02040503050406030204" pitchFamily="18" charset="0"/>
                             </a:rPr>
                           </m:ctrlPr>
@@ -16136,7 +15628,7 @@
                       <m:sSup>
                         <m:sSupPr>
                           <m:ctrlPr>
-                            <a:rPr lang="ar-AE" sz="1600" i="1">
+                            <a:rPr lang="ar-AE" sz="1600">
                               <a:latin typeface="Cambria Math" panose="02040503050406030204" pitchFamily="18" charset="0"/>
                             </a:rPr>
                           </m:ctrlPr>
@@ -16566,11 +16058,11 @@
                     <m:oMathParaPr>
                       <m:jc m:val="center"/>
                     </m:oMathParaPr>
-                    <m:oMath xmlns:m="http://schemas.openxmlformats.org/officeDocument/2006/math">
+                    <m:oMath>
                       <m:f>
                         <m:fPr>
                           <m:ctrlPr>
-                            <a:rPr i="1">
+                            <a:rPr>
                               <a:latin typeface="Cambria Math" panose="02040503050406030204" pitchFamily="18" charset="0"/>
                             </a:rPr>
                           </m:ctrlPr>
@@ -16607,7 +16099,7 @@
                                 <m:accPr>
                                   <m:chr m:val="⃗"/>
                                   <m:ctrlPr>
-                                    <a:rPr i="1">
+                                    <a:rPr>
                                       <a:latin typeface="Cambria Math" panose="02040503050406030204" pitchFamily="18" charset="0"/>
                                     </a:rPr>
                                   </m:ctrlPr>
@@ -16641,7 +16133,7 @@
                             <m:accPr>
                               <m:chr m:val="⃗"/>
                               <m:ctrlPr>
-                                <a:rPr i="1">
+                                <a:rPr>
                                   <a:latin typeface="Cambria Math" panose="02040503050406030204" pitchFamily="18" charset="0"/>
                                 </a:rPr>
                               </m:ctrlPr>
@@ -16668,7 +16160,7 @@
                           <m:chr m:val="∑"/>
                           <m:limLoc m:val="undOvr"/>
                           <m:ctrlPr>
-                            <a:rPr i="1">
+                            <a:rPr>
                               <a:latin typeface="Cambria Math" panose="02040503050406030204" pitchFamily="18" charset="0"/>
                             </a:rPr>
                           </m:ctrlPr>
@@ -16699,7 +16191,7 @@
                           <m:sSubSup>
                             <m:sSubSupPr>
                               <m:ctrlPr>
-                                <a:rPr i="1">
+                                <a:rPr>
                                   <a:latin typeface="Cambria Math" panose="02040503050406030204" pitchFamily="18" charset="0"/>
                                 </a:rPr>
                               </m:ctrlPr>
@@ -16743,7 +16235,7 @@
                           <m:sSub>
                             <m:sSubPr>
                               <m:ctrlPr>
-                                <a:rPr i="1">
+                                <a:rPr>
                                   <a:latin typeface="Cambria Math" panose="02040503050406030204" pitchFamily="18" charset="0"/>
                                 </a:rPr>
                               </m:ctrlPr>
@@ -16774,7 +16266,7 @@
                           <m:sSubSup>
                             <m:sSubSupPr>
                               <m:ctrlPr>
-                                <a:rPr i="1">
+                                <a:rPr>
                                   <a:latin typeface="Cambria Math" panose="02040503050406030204" pitchFamily="18" charset="0"/>
                                 </a:rPr>
                               </m:ctrlPr>
@@ -16808,7 +16300,7 @@
                             <m:accPr>
                               <m:chr m:val="⃗"/>
                               <m:ctrlPr>
-                                <a:rPr i="1">
+                                <a:rPr>
                                   <a:latin typeface="Cambria Math" panose="02040503050406030204" pitchFamily="18" charset="0"/>
                                 </a:rPr>
                               </m:ctrlPr>
@@ -16853,11 +16345,11 @@
                     <m:oMathParaPr>
                       <m:jc m:val="center"/>
                     </m:oMathParaPr>
-                    <m:oMath xmlns:m="http://schemas.openxmlformats.org/officeDocument/2006/math">
+                    <m:oMath>
                       <m:sSup>
                         <m:sSupPr>
                           <m:ctrlPr>
-                            <a:rPr i="1">
+                            <a:rPr>
                               <a:latin typeface="Cambria Math" panose="02040503050406030204" pitchFamily="18" charset="0"/>
                             </a:rPr>
                           </m:ctrlPr>
@@ -16892,7 +16384,7 @@
                             <m:accPr>
                               <m:chr m:val="⃗"/>
                               <m:ctrlPr>
-                                <a:rPr i="1">
+                                <a:rPr>
                                   <a:latin typeface="Cambria Math" panose="02040503050406030204" pitchFamily="18" charset="0"/>
                                 </a:rPr>
                               </m:ctrlPr>
@@ -16922,7 +16414,7 @@
                             <m:accPr>
                               <m:chr m:val="⃗"/>
                               <m:ctrlPr>
-                                <a:rPr i="1">
+                                <a:rPr>
                                   <a:latin typeface="Cambria Math" panose="02040503050406030204" pitchFamily="18" charset="0"/>
                                 </a:rPr>
                               </m:ctrlPr>
@@ -16969,12 +16461,12 @@
                     <m:oMathParaPr>
                       <m:jc m:val="center"/>
                     </m:oMathParaPr>
-                    <m:oMath xmlns:m="http://schemas.openxmlformats.org/officeDocument/2006/math">
+                    <m:oMath>
                       <m:acc>
                         <m:accPr>
                           <m:chr m:val="⃗"/>
                           <m:ctrlPr>
-                            <a:rPr i="1">
+                            <a:rPr>
                               <a:latin typeface="Cambria Math" panose="02040503050406030204" pitchFamily="18" charset="0"/>
                             </a:rPr>
                           </m:ctrlPr>
@@ -17015,7 +16507,7 @@
                               <m:sSup>
                                 <m:sSupPr>
                                   <m:ctrlPr>
-                                    <a:rPr i="1">
+                                    <a:rPr>
                                       <a:latin typeface="Cambria Math" panose="02040503050406030204" pitchFamily="18" charset="0"/>
                                     </a:rPr>
                                   </m:ctrlPr>
@@ -17058,7 +16550,7 @@
                       <m:sSup>
                         <m:sSupPr>
                           <m:ctrlPr>
-                            <a:rPr i="1">
+                            <a:rPr>
                               <a:latin typeface="Cambria Math" panose="02040503050406030204" pitchFamily="18" charset="0"/>
                             </a:rPr>
                           </m:ctrlPr>
@@ -17084,7 +16576,7 @@
                         <m:accPr>
                           <m:chr m:val="̂"/>
                           <m:ctrlPr>
-                            <a:rPr i="1">
+                            <a:rPr>
                               <a:latin typeface="Cambria Math" panose="02040503050406030204" pitchFamily="18" charset="0"/>
                             </a:rPr>
                           </m:ctrlPr>
@@ -17114,7 +16606,7 @@
                     <m:sSup>
                       <m:sSupPr>
                         <m:ctrlPr>
-                          <a:rPr i="1">
+                          <a:rPr>
                             <a:latin typeface="Cambria Math" panose="02040503050406030204" pitchFamily="18" charset="0"/>
                           </a:rPr>
                         </m:ctrlPr>
@@ -17591,25 +17083,7 @@
                       <a:rPr>
                         <a:latin typeface="Cambria Math" panose="02040503050406030204" pitchFamily="18" charset="0"/>
                       </a:rPr>
-                      <m:t>&gt;</m:t>
-                    </m:r>
-                    <m:r>
-                      <a:rPr>
-                        <a:latin typeface="Cambria Math" panose="02040503050406030204" pitchFamily="18" charset="0"/>
-                      </a:rPr>
-                      <m:t>1</m:t>
-                    </m:r>
-                    <m:r>
-                      <a:rPr>
-                        <a:latin typeface="Cambria Math" panose="02040503050406030204" pitchFamily="18" charset="0"/>
-                      </a:rPr>
-                      <m:t>,</m:t>
-                    </m:r>
-                    <m:r>
-                      <a:rPr>
-                        <a:latin typeface="Cambria Math" panose="02040503050406030204" pitchFamily="18" charset="0"/>
-                      </a:rPr>
-                      <m:t>000</m:t>
+                      <m:t>&gt;1,000</m:t>
                     </m:r>
                   </m:oMath>
                 </a14:m>
@@ -17638,11 +17112,11 @@
                     <m:oMathParaPr>
                       <m:jc m:val="center"/>
                     </m:oMathParaPr>
-                    <m:oMath xmlns:m="http://schemas.openxmlformats.org/officeDocument/2006/math">
+                    <m:oMath>
                       <m:sSup>
                         <m:sSupPr>
                           <m:ctrlPr>
-                            <a:rPr i="1">
+                            <a:rPr>
                               <a:latin typeface="Cambria Math" panose="02040503050406030204" pitchFamily="18" charset="0"/>
                             </a:rPr>
                           </m:ctrlPr>
@@ -17677,7 +17151,7 @@
                             <m:accPr>
                               <m:chr m:val="⃗"/>
                               <m:ctrlPr>
-                                <a:rPr i="1">
+                                <a:rPr>
                                   <a:latin typeface="Cambria Math" panose="02040503050406030204" pitchFamily="18" charset="0"/>
                                 </a:rPr>
                               </m:ctrlPr>
@@ -17707,7 +17181,7 @@
                             <m:accPr>
                               <m:chr m:val="⃗"/>
                               <m:ctrlPr>
-                                <a:rPr i="1">
+                                <a:rPr>
                                   <a:latin typeface="Cambria Math" panose="02040503050406030204" pitchFamily="18" charset="0"/>
                                 </a:rPr>
                               </m:ctrlPr>
@@ -17727,13 +17201,7 @@
                         <a:rPr>
                           <a:latin typeface="Cambria Math" panose="02040503050406030204" pitchFamily="18" charset="0"/>
                         </a:rPr>
-                        <m:t>=</m:t>
-                      </m:r>
-                      <m:r>
-                        <a:rPr>
-                          <a:latin typeface="Cambria Math" panose="02040503050406030204" pitchFamily="18" charset="0"/>
-                        </a:rPr>
-                        <m:t>0</m:t>
+                        <m:t>=0</m:t>
                       </m:r>
                     </m:oMath>
                   </m:oMathPara>
@@ -17751,7 +17219,7 @@
                     <m:sSup>
                       <m:sSupPr>
                         <m:ctrlPr>
-                          <a:rPr i="1">
+                          <a:rPr>
                             <a:latin typeface="Cambria Math" panose="02040503050406030204" pitchFamily="18" charset="0"/>
                           </a:rPr>
                         </m:ctrlPr>
@@ -17789,12 +17257,12 @@
                     <m:oMathParaPr>
                       <m:jc m:val="center"/>
                     </m:oMathParaPr>
-                    <m:oMath xmlns:m="http://schemas.openxmlformats.org/officeDocument/2006/math">
+                    <m:oMath>
                       <m:acc>
                         <m:accPr>
                           <m:chr m:val="⃗"/>
                           <m:ctrlPr>
-                            <a:rPr i="1">
+                            <a:rPr>
                               <a:latin typeface="Cambria Math" panose="02040503050406030204" pitchFamily="18" charset="0"/>
                             </a:rPr>
                           </m:ctrlPr>
@@ -17824,7 +17292,7 @@
                         <m:accPr>
                           <m:chr m:val="⃗"/>
                           <m:ctrlPr>
-                            <a:rPr i="1">
+                            <a:rPr>
                               <a:latin typeface="Cambria Math" panose="02040503050406030204" pitchFamily="18" charset="0"/>
                             </a:rPr>
                           </m:ctrlPr>
@@ -17842,13 +17310,7 @@
                         <a:rPr>
                           <a:latin typeface="Cambria Math" panose="02040503050406030204" pitchFamily="18" charset="0"/>
                         </a:rPr>
-                        <m:t>=</m:t>
-                      </m:r>
-                      <m:r>
-                        <a:rPr>
-                          <a:latin typeface="Cambria Math" panose="02040503050406030204" pitchFamily="18" charset="0"/>
-                        </a:rPr>
-                        <m:t>0</m:t>
+                        <m:t>=0</m:t>
                       </m:r>
                     </m:oMath>
                   </m:oMathPara>
@@ -18539,7 +18001,7 @@
                     <m:oMathParaPr>
                       <m:jc m:val="center"/>
                     </m:oMathParaPr>
-                    <m:oMath xmlns:m="http://schemas.openxmlformats.org/officeDocument/2006/math">
+                    <m:oMath>
                       <m:r>
                         <a:rPr lang="en-US">
                           <a:latin typeface="Cambria Math" panose="02040503050406030204" pitchFamily="18" charset="0"/>
@@ -18603,7 +18065,7 @@
                     <m:oMathParaPr>
                       <m:jc m:val="center"/>
                     </m:oMathParaPr>
-                    <m:oMath xmlns:m="http://schemas.openxmlformats.org/officeDocument/2006/math">
+                    <m:oMath>
                       <m:r>
                         <a:rPr lang="en-US">
                           <a:latin typeface="Cambria Math" panose="02040503050406030204" pitchFamily="18" charset="0"/>
@@ -18626,13 +18088,7 @@
                         <a:rPr lang="en-US">
                           <a:latin typeface="Cambria Math" panose="02040503050406030204" pitchFamily="18" charset="0"/>
                         </a:rPr>
-                        <m:t>1</m:t>
-                      </m:r>
-                      <m:r>
-                        <a:rPr lang="en-US">
-                          <a:latin typeface="Cambria Math" panose="02040503050406030204" pitchFamily="18" charset="0"/>
-                        </a:rPr>
-                        <m:t>+</m:t>
+                        <m:t>1+</m:t>
                       </m:r>
                       <m:r>
                         <a:rPr lang="en-US">
@@ -18668,7 +18124,7 @@
                     <m:d>
                       <m:dPr>
                         <m:ctrlPr>
-                          <a:rPr lang="ar-AE" i="1">
+                          <a:rPr lang="ar-AE" b="0" i="1" smtClean="0">
                             <a:latin typeface="Cambria Math" panose="02040503050406030204" pitchFamily="18" charset="0"/>
                           </a:rPr>
                         </m:ctrlPr>
@@ -18702,7 +18158,7 @@
                     <m:oMathParaPr>
                       <m:jc m:val="center"/>
                     </m:oMathParaPr>
-                    <m:oMath xmlns:m="http://schemas.openxmlformats.org/officeDocument/2006/math">
+                    <m:oMath>
                       <m:r>
                         <a:rPr lang="en-US">
                           <a:latin typeface="Cambria Math" panose="02040503050406030204" pitchFamily="18" charset="0"/>
@@ -18725,13 +18181,7 @@
                         <a:rPr lang="en-US">
                           <a:latin typeface="Cambria Math" panose="02040503050406030204" pitchFamily="18" charset="0"/>
                         </a:rPr>
-                        <m:t>1</m:t>
-                      </m:r>
-                      <m:r>
-                        <a:rPr lang="en-US">
-                          <a:latin typeface="Cambria Math" panose="02040503050406030204" pitchFamily="18" charset="0"/>
-                        </a:rPr>
-                        <m:t>+</m:t>
+                        <m:t>1+</m:t>
                       </m:r>
                       <m:r>
                         <a:rPr lang="en-US">
@@ -18742,7 +18192,7 @@
                       <m:d>
                         <m:dPr>
                           <m:ctrlPr>
-                            <a:rPr lang="ar-AE" i="1">
+                            <a:rPr lang="ar-AE">
                               <a:latin typeface="Cambria Math" panose="02040503050406030204" pitchFamily="18" charset="0"/>
                             </a:rPr>
                           </m:ctrlPr>
@@ -18758,19 +18208,7 @@
                             <a:rPr lang="ar-AE">
                               <a:latin typeface="Cambria Math" panose="02040503050406030204" pitchFamily="18" charset="0"/>
                             </a:rPr>
-                            <m:t>1</m:t>
-                          </m:r>
-                          <m:r>
-                            <a:rPr lang="ar-AE">
-                              <a:latin typeface="Cambria Math" panose="02040503050406030204" pitchFamily="18" charset="0"/>
-                            </a:rPr>
-                            <m:t>∗∗</m:t>
-                          </m:r>
-                          <m:r>
-                            <a:rPr lang="ar-AE">
-                              <a:latin typeface="Cambria Math" panose="02040503050406030204" pitchFamily="18" charset="0"/>
-                            </a:rPr>
-                            <m:t>2</m:t>
+                            <m:t>1∗∗2</m:t>
                           </m:r>
                         </m:e>
                       </m:d>
@@ -19265,7 +18703,7 @@
                     <m:oMathParaPr>
                       <m:jc m:val="center"/>
                     </m:oMathParaPr>
-                    <m:oMath xmlns:m="http://schemas.openxmlformats.org/officeDocument/2006/math">
+                    <m:oMath>
                       <m:r>
                         <a:rPr lang="en-US" sz="2000">
                           <a:latin typeface="Cambria Math" panose="02040503050406030204" pitchFamily="18" charset="0"/>
@@ -19276,19 +18714,7 @@
                         <a:rPr lang="en-US" sz="2000">
                           <a:latin typeface="Cambria Math" panose="02040503050406030204" pitchFamily="18" charset="0"/>
                         </a:rPr>
-                        <m:t>∼−</m:t>
-                      </m:r>
-                      <m:r>
-                        <a:rPr lang="en-US" sz="2000">
-                          <a:latin typeface="Cambria Math" panose="02040503050406030204" pitchFamily="18" charset="0"/>
-                        </a:rPr>
-                        <m:t>1</m:t>
-                      </m:r>
-                      <m:r>
-                        <a:rPr lang="en-US" sz="2000">
-                          <a:latin typeface="Cambria Math" panose="02040503050406030204" pitchFamily="18" charset="0"/>
-                        </a:rPr>
-                        <m:t>+</m:t>
+                        <m:t>∼−1+</m:t>
                       </m:r>
                       <m:r>
                         <a:rPr lang="en-US" sz="2000">
@@ -19300,13 +18726,7 @@
                         <a:rPr lang="en-US" sz="2000">
                           <a:latin typeface="Cambria Math" panose="02040503050406030204" pitchFamily="18" charset="0"/>
                         </a:rPr>
-                        <m:t>1</m:t>
-                      </m:r>
-                      <m:r>
-                        <a:rPr lang="en-US" sz="2000">
-                          <a:latin typeface="Cambria Math" panose="02040503050406030204" pitchFamily="18" charset="0"/>
-                        </a:rPr>
-                        <m:t>∗</m:t>
+                        <m:t>1∗</m:t>
                       </m:r>
                       <m:r>
                         <a:rPr lang="en-US" sz="2000">
@@ -19318,13 +18738,7 @@
                         <a:rPr lang="en-US" sz="2000">
                           <a:latin typeface="Cambria Math" panose="02040503050406030204" pitchFamily="18" charset="0"/>
                         </a:rPr>
-                        <m:t>2</m:t>
-                      </m:r>
-                      <m:r>
-                        <a:rPr lang="en-US" sz="2000">
-                          <a:latin typeface="Cambria Math" panose="02040503050406030204" pitchFamily="18" charset="0"/>
-                        </a:rPr>
-                        <m:t>↔</m:t>
+                        <m:t>2↔</m:t>
                       </m:r>
                       <m:r>
                         <a:rPr lang="en-US" sz="2000">
@@ -19336,19 +18750,7 @@
                         <a:rPr lang="en-US" sz="2000">
                           <a:latin typeface="Cambria Math" panose="02040503050406030204" pitchFamily="18" charset="0"/>
                         </a:rPr>
-                        <m:t>∼−</m:t>
-                      </m:r>
-                      <m:r>
-                        <a:rPr lang="en-US" sz="2000">
-                          <a:latin typeface="Cambria Math" panose="02040503050406030204" pitchFamily="18" charset="0"/>
-                        </a:rPr>
-                        <m:t>1</m:t>
-                      </m:r>
-                      <m:r>
-                        <a:rPr lang="en-US" sz="2000">
-                          <a:latin typeface="Cambria Math" panose="02040503050406030204" pitchFamily="18" charset="0"/>
-                        </a:rPr>
-                        <m:t>+</m:t>
+                        <m:t>∼−1+</m:t>
                       </m:r>
                       <m:r>
                         <a:rPr lang="en-US" sz="2000">
@@ -19360,13 +18762,7 @@
                         <a:rPr lang="en-US" sz="2000">
                           <a:latin typeface="Cambria Math" panose="02040503050406030204" pitchFamily="18" charset="0"/>
                         </a:rPr>
-                        <m:t>1</m:t>
-                      </m:r>
-                      <m:r>
-                        <a:rPr lang="en-US" sz="2000">
-                          <a:latin typeface="Cambria Math" panose="02040503050406030204" pitchFamily="18" charset="0"/>
-                        </a:rPr>
-                        <m:t>+</m:t>
+                        <m:t>1+</m:t>
                       </m:r>
                       <m:r>
                         <a:rPr lang="en-US" sz="2000">
@@ -19378,13 +18774,7 @@
                         <a:rPr lang="en-US" sz="2000">
                           <a:latin typeface="Cambria Math" panose="02040503050406030204" pitchFamily="18" charset="0"/>
                         </a:rPr>
-                        <m:t>2</m:t>
-                      </m:r>
-                      <m:r>
-                        <a:rPr lang="en-US" sz="2000">
-                          <a:latin typeface="Cambria Math" panose="02040503050406030204" pitchFamily="18" charset="0"/>
-                        </a:rPr>
-                        <m:t>+</m:t>
+                        <m:t>2+</m:t>
                       </m:r>
                       <m:r>
                         <a:rPr lang="en-US" sz="2000">
@@ -19396,13 +18786,7 @@
                         <a:rPr lang="en-US" sz="2000">
                           <a:latin typeface="Cambria Math" panose="02040503050406030204" pitchFamily="18" charset="0"/>
                         </a:rPr>
-                        <m:t>1</m:t>
-                      </m:r>
-                      <m:r>
-                        <a:rPr lang="en-US" sz="2000">
-                          <a:latin typeface="Cambria Math" panose="02040503050406030204" pitchFamily="18" charset="0"/>
-                        </a:rPr>
-                        <m:t>:</m:t>
+                        <m:t>1:</m:t>
                       </m:r>
                       <m:r>
                         <a:rPr lang="en-US" sz="2000">
@@ -19431,13 +18815,7 @@
                       <a:rPr lang="en-US" sz="2000" b="0" i="1" smtClean="0">
                         <a:latin typeface="Cambria Math" panose="02040503050406030204" pitchFamily="18" charset="0"/>
                       </a:rPr>
-                      <m:t>−</m:t>
-                    </m:r>
-                    <m:r>
-                      <a:rPr lang="en-US" sz="2000" b="0" i="1" smtClean="0">
-                        <a:latin typeface="Cambria Math" panose="02040503050406030204" pitchFamily="18" charset="0"/>
-                      </a:rPr>
-                      <m:t>1</m:t>
+                      <m:t>−1</m:t>
                     </m:r>
                   </m:oMath>
                 </a14:m>
@@ -19466,7 +18844,7 @@
                     <m:oMathParaPr>
                       <m:jc m:val="center"/>
                     </m:oMathParaPr>
-                    <m:oMath xmlns:m="http://schemas.openxmlformats.org/officeDocument/2006/math">
+                    <m:oMath>
                       <m:r>
                         <a:rPr lang="en-US" sz="2200">
                           <a:latin typeface="Cambria Math" panose="02040503050406030204" pitchFamily="18" charset="0"/>
@@ -19489,13 +18867,7 @@
                         <a:rPr lang="en-US" sz="2200">
                           <a:latin typeface="Cambria Math" panose="02040503050406030204" pitchFamily="18" charset="0"/>
                         </a:rPr>
-                        <m:t>1</m:t>
-                      </m:r>
-                      <m:r>
-                        <a:rPr lang="en-US" sz="2200">
-                          <a:latin typeface="Cambria Math" panose="02040503050406030204" pitchFamily="18" charset="0"/>
-                        </a:rPr>
-                        <m:t>+</m:t>
+                        <m:t>1+</m:t>
                       </m:r>
                       <m:r>
                         <a:rPr lang="en-US" sz="2200">
@@ -19506,7 +18878,7 @@
                       <m:d>
                         <m:dPr>
                           <m:ctrlPr>
-                            <a:rPr lang="ar-AE" sz="2200" i="1">
+                            <a:rPr lang="ar-AE" sz="2200">
                               <a:latin typeface="Cambria Math" panose="02040503050406030204" pitchFamily="18" charset="0"/>
                             </a:rPr>
                           </m:ctrlPr>
@@ -20129,7 +19501,7 @@
                     <m:d>
                       <m:dPr>
                         <m:ctrlPr>
-                          <a:rPr i="1">
+                          <a:rPr>
                             <a:latin typeface="Cambria Math" panose="02040503050406030204" pitchFamily="18" charset="0"/>
                           </a:rPr>
                         </m:ctrlPr>
@@ -20139,19 +19511,7 @@
                           <a:rPr>
                             <a:latin typeface="Cambria Math" panose="02040503050406030204" pitchFamily="18" charset="0"/>
                           </a:rPr>
-                          <m:t>0</m:t>
-                        </m:r>
-                        <m:r>
-                          <a:rPr>
-                            <a:latin typeface="Cambria Math" panose="02040503050406030204" pitchFamily="18" charset="0"/>
-                          </a:rPr>
-                          <m:t>,</m:t>
-                        </m:r>
-                        <m:r>
-                          <a:rPr>
-                            <a:latin typeface="Cambria Math" panose="02040503050406030204" pitchFamily="18" charset="0"/>
-                          </a:rPr>
-                          <m:t>2</m:t>
+                          <m:t>0,2</m:t>
                         </m:r>
                       </m:e>
                     </m:d>
@@ -20171,13 +19531,7 @@
                       <a:rPr>
                         <a:latin typeface="Cambria Math" panose="02040503050406030204" pitchFamily="18" charset="0"/>
                       </a:rPr>
-                      <m:t>=</m:t>
-                    </m:r>
-                    <m:r>
-                      <a:rPr>
-                        <a:latin typeface="Cambria Math" panose="02040503050406030204" pitchFamily="18" charset="0"/>
-                      </a:rPr>
-                      <m:t>0</m:t>
+                      <m:t>=0</m:t>
                     </m:r>
                   </m:oMath>
                 </a14:m>
@@ -20191,25 +19545,7 @@
                       <a:rPr>
                         <a:latin typeface="Cambria Math" panose="02040503050406030204" pitchFamily="18" charset="0"/>
                       </a:rPr>
-                      <m:t>=</m:t>
-                    </m:r>
-                    <m:r>
-                      <a:rPr>
-                        <a:latin typeface="Cambria Math" panose="02040503050406030204" pitchFamily="18" charset="0"/>
-                      </a:rPr>
-                      <m:t>1</m:t>
-                    </m:r>
-                    <m:r>
-                      <a:rPr>
-                        <a:latin typeface="Cambria Math" panose="02040503050406030204" pitchFamily="18" charset="0"/>
-                      </a:rPr>
-                      <m:t>.</m:t>
-                    </m:r>
-                    <m:r>
-                      <a:rPr>
-                        <a:latin typeface="Cambria Math" panose="02040503050406030204" pitchFamily="18" charset="0"/>
-                      </a:rPr>
-                      <m:t>0</m:t>
+                      <m:t>=1.0</m:t>
                     </m:r>
                   </m:oMath>
                 </a14:m>
@@ -21058,13 +20394,7 @@
                       <a:rPr lang="en-US" b="0" i="1" smtClean="0">
                         <a:latin typeface="Cambria Math" panose="02040503050406030204" pitchFamily="18" charset="0"/>
                       </a:rPr>
-                      <m:t>=</m:t>
-                    </m:r>
-                    <m:r>
-                      <a:rPr lang="en-US" b="0" i="1" smtClean="0">
-                        <a:latin typeface="Cambria Math" panose="02040503050406030204" pitchFamily="18" charset="0"/>
-                      </a:rPr>
-                      <m:t>0</m:t>
+                      <m:t>=0</m:t>
                     </m:r>
                   </m:oMath>
                 </a14:m>
@@ -21712,25 +21042,7 @@
                       <a:rPr lang="en-US" sz="2000" b="0" i="1" smtClean="0">
                         <a:latin typeface="Cambria Math" panose="02040503050406030204" pitchFamily="18" charset="0"/>
                       </a:rPr>
-                      <m:t>=</m:t>
-                    </m:r>
-                    <m:r>
-                      <a:rPr lang="en-US" sz="2000" b="0" i="1" smtClean="0">
-                        <a:latin typeface="Cambria Math" panose="02040503050406030204" pitchFamily="18" charset="0"/>
-                      </a:rPr>
-                      <m:t>6</m:t>
-                    </m:r>
-                    <m:r>
-                      <a:rPr lang="en-US" sz="2000" b="0" i="1" smtClean="0">
-                        <a:latin typeface="Cambria Math" panose="02040503050406030204" pitchFamily="18" charset="0"/>
-                      </a:rPr>
-                      <m:t>.</m:t>
-                    </m:r>
-                    <m:r>
-                      <a:rPr lang="en-US" sz="2000" b="0" i="1" smtClean="0">
-                        <a:latin typeface="Cambria Math" panose="02040503050406030204" pitchFamily="18" charset="0"/>
-                      </a:rPr>
-                      <m:t>02</m:t>
+                      <m:t>=6.02</m:t>
                     </m:r>
                   </m:oMath>
                 </a14:m>
@@ -22718,12 +22030,12 @@
                     <m:oMathParaPr>
                       <m:jc m:val="center"/>
                     </m:oMathParaPr>
-                    <m:oMath xmlns:m="http://schemas.openxmlformats.org/officeDocument/2006/math">
+                    <m:oMath>
                       <m:acc>
                         <m:accPr>
                           <m:chr m:val="⃗"/>
                           <m:ctrlPr>
-                            <a:rPr i="1">
+                            <a:rPr>
                               <a:latin typeface="Cambria Math" panose="02040503050406030204" pitchFamily="18" charset="0"/>
                             </a:rPr>
                           </m:ctrlPr>
@@ -22747,7 +22059,7 @@
                         <m:accPr>
                           <m:chr m:val="⃗"/>
                           <m:ctrlPr>
-                            <a:rPr i="1">
+                            <a:rPr>
                               <a:latin typeface="Cambria Math" panose="02040503050406030204" pitchFamily="18" charset="0"/>
                             </a:rPr>
                           </m:ctrlPr>
@@ -22783,7 +22095,7 @@
                         <m:accPr>
                           <m:chr m:val="⃗"/>
                           <m:ctrlPr>
-                            <a:rPr i="1">
+                            <a:rPr>
                               <a:latin typeface="Cambria Math" panose="02040503050406030204" pitchFamily="18" charset="0"/>
                             </a:rPr>
                           </m:ctrlPr>
@@ -22807,7 +22119,7 @@
                         <m:accPr>
                           <m:chr m:val="⃗"/>
                           <m:ctrlPr>
-                            <a:rPr i="1">
+                            <a:rPr>
                               <a:latin typeface="Cambria Math" panose="02040503050406030204" pitchFamily="18" charset="0"/>
                             </a:rPr>
                           </m:ctrlPr>
@@ -22831,7 +22143,7 @@
                         <m:accPr>
                           <m:chr m:val="̂"/>
                           <m:ctrlPr>
-                            <a:rPr i="1">
+                            <a:rPr>
                               <a:latin typeface="Cambria Math" panose="02040503050406030204" pitchFamily="18" charset="0"/>
                             </a:rPr>
                           </m:ctrlPr>
@@ -22880,12 +22192,12 @@
                     <m:oMathParaPr>
                       <m:jc m:val="center"/>
                     </m:oMathParaPr>
-                    <m:oMath xmlns:m="http://schemas.openxmlformats.org/officeDocument/2006/math">
+                    <m:oMath>
                       <m:acc>
                         <m:accPr>
                           <m:chr m:val="⃗"/>
                           <m:ctrlPr>
-                            <a:rPr i="1">
+                            <a:rPr>
                               <a:latin typeface="Cambria Math" panose="02040503050406030204" pitchFamily="18" charset="0"/>
                             </a:rPr>
                           </m:ctrlPr>
@@ -22914,7 +22226,7 @@
                       <m:d>
                         <m:dPr>
                           <m:ctrlPr>
-                            <a:rPr i="1">
+                            <a:rPr>
                               <a:latin typeface="Cambria Math" panose="02040503050406030204" pitchFamily="18" charset="0"/>
                             </a:rPr>
                           </m:ctrlPr>
@@ -22924,18 +22236,12 @@
                             <a:rPr>
                               <a:latin typeface="Cambria Math" panose="02040503050406030204" pitchFamily="18" charset="0"/>
                             </a:rPr>
-                            <m:t>0</m:t>
-                          </m:r>
-                          <m:r>
-                            <a:rPr>
-                              <a:latin typeface="Cambria Math" panose="02040503050406030204" pitchFamily="18" charset="0"/>
-                            </a:rPr>
-                            <m:t>,</m:t>
+                            <m:t>0,</m:t>
                           </m:r>
                           <m:sSup>
                             <m:sSupPr>
                               <m:ctrlPr>
-                                <a:rPr i="1">
+                                <a:rPr>
                                   <a:latin typeface="Cambria Math" panose="02040503050406030204" pitchFamily="18" charset="0"/>
                                 </a:rPr>
                               </m:ctrlPr>
@@ -24709,10 +24015,7 @@
                 </a:pPr>
                 <a14:m>
                   <m:oMathPara xmlns:m="http://schemas.openxmlformats.org/officeDocument/2006/math">
-                    <m:oMathParaPr>
-                      <m:jc m:val="centerGroup"/>
-                    </m:oMathParaPr>
-                    <m:oMath xmlns:m="http://schemas.openxmlformats.org/officeDocument/2006/math">
+                    <m:oMath>
                       <m:acc>
                         <m:accPr>
                           <m:chr m:val="̅"/>
@@ -24771,10 +24074,7 @@
                 </a:pPr>
                 <a14:m>
                   <m:oMathPara xmlns:m="http://schemas.openxmlformats.org/officeDocument/2006/math">
-                    <m:oMathParaPr>
-                      <m:jc m:val="centerGroup"/>
-                    </m:oMathParaPr>
-                    <m:oMath xmlns:m="http://schemas.openxmlformats.org/officeDocument/2006/math">
+                    <m:oMath>
                       <m:r>
                         <a:rPr lang="en-US" b="1" i="1" smtClean="0">
                           <a:latin typeface="Cambria Math" panose="02040503050406030204" pitchFamily="18" charset="0"/>
@@ -24950,10 +24250,7 @@
                 </a:pPr>
                 <a14:m>
                   <m:oMathPara xmlns:m="http://schemas.openxmlformats.org/officeDocument/2006/math">
-                    <m:oMathParaPr>
-                      <m:jc m:val="centerGroup"/>
-                    </m:oMathParaPr>
-                    <m:oMath xmlns:m="http://schemas.openxmlformats.org/officeDocument/2006/math">
+                    <m:oMath>
                       <m:r>
                         <a:rPr lang="en-US" b="1" i="1">
                           <a:latin typeface="Cambria Math" panose="02040503050406030204" pitchFamily="18" charset="0"/>
@@ -25049,7 +24346,7 @@
                               <m:d>
                                 <m:dPr>
                                   <m:ctrlPr>
-                                    <a:rPr lang="en-US" i="1">
+                                    <a:rPr lang="en-US" i="1" smtClean="0">
                                       <a:latin typeface="Cambria Math" panose="02040503050406030204" pitchFamily="18" charset="0"/>
                                     </a:rPr>
                                   </m:ctrlPr>
@@ -25068,7 +24365,7 @@
                                         <m:accPr>
                                           <m:chr m:val="̂"/>
                                           <m:ctrlPr>
-                                            <a:rPr lang="en-US" i="1" smtClean="0">
+                                            <a:rPr lang="en-US" b="0" i="1" smtClean="0">
                                               <a:latin typeface="Cambria Math" panose="02040503050406030204" pitchFamily="18" charset="0"/>
                                             </a:rPr>
                                           </m:ctrlPr>
@@ -25141,10 +24438,7 @@
                 </a:pPr>
                 <a14:m>
                   <m:oMathPara xmlns:m="http://schemas.openxmlformats.org/officeDocument/2006/math">
-                    <m:oMathParaPr>
-                      <m:jc m:val="centerGroup"/>
-                    </m:oMathParaPr>
-                    <m:oMath xmlns:m="http://schemas.openxmlformats.org/officeDocument/2006/math">
+                    <m:oMath>
                       <m:r>
                         <a:rPr lang="en-US" b="1" i="1" smtClean="0">
                           <a:latin typeface="Cambria Math" panose="02040503050406030204" pitchFamily="18" charset="0"/>
@@ -25351,7 +24645,7 @@
                     <m:oMathParaPr>
                       <m:jc m:val="center"/>
                     </m:oMathParaPr>
-                    <m:oMath xmlns:m="http://schemas.openxmlformats.org/officeDocument/2006/math">
+                    <m:oMath>
                       <m:r>
                         <a:rPr lang="en-US">
                           <a:latin typeface="Cambria Math" panose="02040503050406030204" pitchFamily="18" charset="0"/>
@@ -25405,7 +24699,7 @@
                     <m:oMathParaPr>
                       <m:jc m:val="center"/>
                     </m:oMathParaPr>
-                    <m:oMath xmlns:m="http://schemas.openxmlformats.org/officeDocument/2006/math">
+                    <m:oMath>
                       <m:r>
                         <a:rPr lang="en-US">
                           <a:latin typeface="Cambria Math" panose="02040503050406030204" pitchFamily="18" charset="0"/>
@@ -26242,7 +25536,7 @@
                     <m:oMathParaPr>
                       <m:jc m:val="center"/>
                     </m:oMathParaPr>
-                    <m:oMath xmlns:m="http://schemas.openxmlformats.org/officeDocument/2006/math">
+                    <m:oMath>
                       <m:r>
                         <a:rPr lang="en-US">
                           <a:latin typeface="Cambria Math" panose="02040503050406030204" pitchFamily="18" charset="0"/>
@@ -26288,7 +25582,7 @@
                     <m:f>
                       <m:fPr>
                         <m:ctrlPr>
-                          <a:rPr lang="ar-AE" i="1">
+                          <a:rPr lang="ar-AE">
                             <a:latin typeface="Cambria Math" panose="02040503050406030204" pitchFamily="18" charset="0"/>
                           </a:rPr>
                         </m:ctrlPr>
@@ -26371,11 +25665,11 @@
                     <m:oMathParaPr>
                       <m:jc m:val="center"/>
                     </m:oMathParaPr>
-                    <m:oMath xmlns:m="http://schemas.openxmlformats.org/officeDocument/2006/math">
+                    <m:oMath>
                       <m:sSup>
                         <m:sSupPr>
                           <m:ctrlPr>
-                            <a:rPr lang="ar-AE" i="1">
+                            <a:rPr lang="ar-AE">
                               <a:latin typeface="Cambria Math" panose="02040503050406030204" pitchFamily="18" charset="0"/>
                             </a:rPr>
                           </m:ctrlPr>
@@ -26401,24 +25695,12 @@
                         <a:rPr lang="ar-AE">
                           <a:latin typeface="Cambria Math" panose="02040503050406030204" pitchFamily="18" charset="0"/>
                         </a:rPr>
-                        <m:t>=</m:t>
-                      </m:r>
-                      <m:r>
-                        <a:rPr lang="ar-AE">
-                          <a:latin typeface="Cambria Math" panose="02040503050406030204" pitchFamily="18" charset="0"/>
-                        </a:rPr>
-                        <m:t>1</m:t>
-                      </m:r>
-                      <m:r>
-                        <a:rPr lang="ar-AE">
-                          <a:latin typeface="Cambria Math" panose="02040503050406030204" pitchFamily="18" charset="0"/>
-                        </a:rPr>
-                        <m:t>−</m:t>
+                        <m:t>=1−</m:t>
                       </m:r>
                       <m:f>
                         <m:fPr>
                           <m:ctrlPr>
-                            <a:rPr lang="ar-AE" i="1">
+                            <a:rPr lang="ar-AE">
                               <a:latin typeface="Cambria Math" panose="02040503050406030204" pitchFamily="18" charset="0"/>
                             </a:rPr>
                           </m:ctrlPr>
@@ -26444,13 +25726,7 @@
                         <a:rPr lang="en-US" b="0" i="1" smtClean="0">
                           <a:latin typeface="Cambria Math" panose="02040503050406030204" pitchFamily="18" charset="0"/>
                         </a:rPr>
-                        <m:t>,    </m:t>
-                      </m:r>
-                      <m:r>
-                        <a:rPr lang="en-US" b="0" i="1" smtClean="0">
-                          <a:latin typeface="Cambria Math" panose="02040503050406030204" pitchFamily="18" charset="0"/>
-                        </a:rPr>
-                        <m:t>0</m:t>
+                        <m:t>,    0</m:t>
                       </m:r>
                       <m:r>
                         <a:rPr lang="en-US" b="0" i="1" smtClean="0">
@@ -26462,7 +25738,7 @@
                       <m:sSup>
                         <m:sSupPr>
                           <m:ctrlPr>
-                            <a:rPr lang="ar-AE" i="1">
+                            <a:rPr lang="ar-AE">
                               <a:latin typeface="Cambria Math" panose="02040503050406030204" pitchFamily="18" charset="0"/>
                             </a:rPr>
                           </m:ctrlPr>
@@ -26489,14 +25765,7 @@
                           <a:latin typeface="Cambria Math" panose="02040503050406030204" pitchFamily="18" charset="0"/>
                           <a:ea typeface="Cambria Math" panose="02040503050406030204" pitchFamily="18" charset="0"/>
                         </a:rPr>
-                        <m:t>≤</m:t>
-                      </m:r>
-                      <m:r>
-                        <a:rPr lang="en-US" b="0" i="1" smtClean="0">
-                          <a:latin typeface="Cambria Math" panose="02040503050406030204" pitchFamily="18" charset="0"/>
-                          <a:ea typeface="Cambria Math" panose="02040503050406030204" pitchFamily="18" charset="0"/>
-                        </a:rPr>
-                        <m:t>1</m:t>
+                        <m:t>≤1</m:t>
                       </m:r>
                     </m:oMath>
                   </m:oMathPara>
@@ -26517,7 +25786,7 @@
                     <m:sSup>
                       <m:sSupPr>
                         <m:ctrlPr>
-                          <a:rPr lang="ar-AE" i="1">
+                          <a:rPr lang="ar-AE">
                             <a:latin typeface="Cambria Math" panose="02040503050406030204" pitchFamily="18" charset="0"/>
                           </a:rPr>
                         </m:ctrlPr>
@@ -26552,10 +25821,7 @@
                 </a:pPr>
                 <a14:m>
                   <m:oMathPara xmlns:m="http://schemas.openxmlformats.org/officeDocument/2006/math">
-                    <m:oMathParaPr>
-                      <m:jc m:val="centerGroup"/>
-                    </m:oMathParaPr>
-                    <m:oMath xmlns:m="http://schemas.openxmlformats.org/officeDocument/2006/math">
+                    <m:oMath>
                       <m:r>
                         <a:rPr lang="en-US" b="0" i="1" smtClean="0">
                           <a:latin typeface="Cambria Math" panose="02040503050406030204" pitchFamily="18" charset="0"/>
@@ -26567,14 +25833,7 @@
                           <a:latin typeface="Cambria Math" panose="02040503050406030204" pitchFamily="18" charset="0"/>
                           <a:ea typeface="Cambria Math" panose="02040503050406030204" pitchFamily="18" charset="0"/>
                         </a:rPr>
-                        <m:t>→</m:t>
-                      </m:r>
-                      <m:r>
-                        <a:rPr lang="en-US" b="0" i="1" smtClean="0">
-                          <a:latin typeface="Cambria Math" panose="02040503050406030204" pitchFamily="18" charset="0"/>
-                          <a:ea typeface="Cambria Math" panose="02040503050406030204" pitchFamily="18" charset="0"/>
-                        </a:rPr>
-                        <m:t>0</m:t>
+                        <m:t>→0</m:t>
                       </m:r>
                     </m:oMath>
                   </m:oMathPara>
@@ -26589,14 +25848,11 @@
                 </a:pPr>
                 <a14:m>
                   <m:oMathPara xmlns:m="http://schemas.openxmlformats.org/officeDocument/2006/math">
-                    <m:oMathParaPr>
-                      <m:jc m:val="centerGroup"/>
-                    </m:oMathParaPr>
-                    <m:oMath xmlns:m="http://schemas.openxmlformats.org/officeDocument/2006/math">
+                    <m:oMath>
                       <m:sSup>
                         <m:sSupPr>
                           <m:ctrlPr>
-                            <a:rPr lang="ar-AE" i="1">
+                            <a:rPr lang="ar-AE">
                               <a:latin typeface="Cambria Math" panose="02040503050406030204" pitchFamily="18" charset="0"/>
                             </a:rPr>
                           </m:ctrlPr>
@@ -26623,14 +25879,7 @@
                           <a:latin typeface="Cambria Math" panose="02040503050406030204" pitchFamily="18" charset="0"/>
                           <a:ea typeface="Cambria Math" panose="02040503050406030204" pitchFamily="18" charset="0"/>
                         </a:rPr>
-                        <m:t>→</m:t>
-                      </m:r>
-                      <m:r>
-                        <a:rPr lang="en-US" b="0" i="1" smtClean="0">
-                          <a:latin typeface="Cambria Math" panose="02040503050406030204" pitchFamily="18" charset="0"/>
-                          <a:ea typeface="Cambria Math" panose="02040503050406030204" pitchFamily="18" charset="0"/>
-                        </a:rPr>
-                        <m:t>1</m:t>
+                        <m:t>→1</m:t>
                       </m:r>
                     </m:oMath>
                   </m:oMathPara>
@@ -26665,10 +25914,7 @@
                 </a:pPr>
                 <a14:m>
                   <m:oMathPara xmlns:m="http://schemas.openxmlformats.org/officeDocument/2006/math">
-                    <m:oMathParaPr>
-                      <m:jc m:val="centerGroup"/>
-                    </m:oMathParaPr>
-                    <m:oMath xmlns:m="http://schemas.openxmlformats.org/officeDocument/2006/math">
+                    <m:oMath>
                       <m:r>
                         <a:rPr lang="en-US" b="0" i="1" smtClean="0">
                           <a:latin typeface="Cambria Math" panose="02040503050406030204" pitchFamily="18" charset="0"/>
@@ -26702,14 +25948,11 @@
                 </a:pPr>
                 <a14:m>
                   <m:oMathPara xmlns:m="http://schemas.openxmlformats.org/officeDocument/2006/math">
-                    <m:oMathParaPr>
-                      <m:jc m:val="centerGroup"/>
-                    </m:oMathParaPr>
-                    <m:oMath xmlns:m="http://schemas.openxmlformats.org/officeDocument/2006/math">
+                    <m:oMath>
                       <m:sSup>
                         <m:sSupPr>
                           <m:ctrlPr>
-                            <a:rPr lang="ar-AE" i="1">
+                            <a:rPr lang="ar-AE">
                               <a:latin typeface="Cambria Math" panose="02040503050406030204" pitchFamily="18" charset="0"/>
                             </a:rPr>
                           </m:ctrlPr>
@@ -26736,14 +25979,7 @@
                           <a:latin typeface="Cambria Math" panose="02040503050406030204" pitchFamily="18" charset="0"/>
                           <a:ea typeface="Cambria Math" panose="02040503050406030204" pitchFamily="18" charset="0"/>
                         </a:rPr>
-                        <m:t>→</m:t>
-                      </m:r>
-                      <m:r>
-                        <a:rPr lang="en-US" b="0" i="1" smtClean="0">
-                          <a:latin typeface="Cambria Math" panose="02040503050406030204" pitchFamily="18" charset="0"/>
-                          <a:ea typeface="Cambria Math" panose="02040503050406030204" pitchFamily="18" charset="0"/>
-                        </a:rPr>
-                        <m:t>0</m:t>
+                        <m:t>→0</m:t>
                       </m:r>
                     </m:oMath>
                   </m:oMathPara>
@@ -27242,7 +26478,7 @@
                     <m:sSup>
                       <m:sSupPr>
                         <m:ctrlPr>
-                          <a:rPr lang="ar-AE" i="1">
+                          <a:rPr lang="ar-AE">
                             <a:latin typeface="Cambria Math" panose="02040503050406030204" pitchFamily="18" charset="0"/>
                           </a:rPr>
                         </m:ctrlPr>
@@ -27274,14 +26510,11 @@
                 </a:pPr>
                 <a14:m>
                   <m:oMathPara xmlns:m="http://schemas.openxmlformats.org/officeDocument/2006/math">
-                    <m:oMathParaPr>
-                      <m:jc m:val="centerGroup"/>
-                    </m:oMathParaPr>
-                    <m:oMath xmlns:m="http://schemas.openxmlformats.org/officeDocument/2006/math">
+                    <m:oMath>
                       <m:sSubSup>
                         <m:sSubSupPr>
                           <m:ctrlPr>
-                            <a:rPr lang="ar-AE" i="1" smtClean="0">
+                            <a:rPr lang="ar-AE" b="0" i="1" smtClean="0">
                               <a:latin typeface="Cambria Math" panose="02040503050406030204" pitchFamily="18" charset="0"/>
                             </a:rPr>
                           </m:ctrlPr>
@@ -27315,19 +26548,7 @@
                         <a:rPr lang="en-US" b="0" i="1" smtClean="0">
                           <a:latin typeface="Cambria Math" panose="02040503050406030204" pitchFamily="18" charset="0"/>
                         </a:rPr>
-                        <m:t>=</m:t>
-                      </m:r>
-                      <m:r>
-                        <a:rPr lang="en-US" b="0" i="1" smtClean="0">
-                          <a:latin typeface="Cambria Math" panose="02040503050406030204" pitchFamily="18" charset="0"/>
-                        </a:rPr>
-                        <m:t>1</m:t>
-                      </m:r>
-                      <m:r>
-                        <a:rPr lang="en-US" b="0" i="1" smtClean="0">
-                          <a:latin typeface="Cambria Math" panose="02040503050406030204" pitchFamily="18" charset="0"/>
-                        </a:rPr>
-                        <m:t>−</m:t>
+                        <m:t>=1−</m:t>
                       </m:r>
                       <m:f>
                         <m:fPr>
@@ -27434,19 +26655,7 @@
                         <a:rPr lang="en-US" b="0" i="1" smtClean="0">
                           <a:latin typeface="Cambria Math" panose="02040503050406030204" pitchFamily="18" charset="0"/>
                         </a:rPr>
-                        <m:t>=</m:t>
-                      </m:r>
-                      <m:r>
-                        <a:rPr lang="en-US" b="0" i="1" smtClean="0">
-                          <a:latin typeface="Cambria Math" panose="02040503050406030204" pitchFamily="18" charset="0"/>
-                        </a:rPr>
-                        <m:t>1</m:t>
-                      </m:r>
-                      <m:r>
-                        <a:rPr lang="en-US" b="0" i="1" smtClean="0">
-                          <a:latin typeface="Cambria Math" panose="02040503050406030204" pitchFamily="18" charset="0"/>
-                        </a:rPr>
-                        <m:t>−</m:t>
+                        <m:t>=1−</m:t>
                       </m:r>
                       <m:f>
                         <m:fPr>
@@ -27529,7 +26738,7 @@
                     <m:sSub>
                       <m:sSubPr>
                         <m:ctrlPr>
-                          <a:rPr lang="en-US" i="1" smtClean="0">
+                          <a:rPr lang="en-US" b="0" i="1" smtClean="0">
                             <a:latin typeface="Cambria Math" panose="02040503050406030204" pitchFamily="18" charset="0"/>
                           </a:rPr>
                         </m:ctrlPr>
@@ -27885,8 +27094,8 @@
           </a:p>
         </p:txBody>
       </p:sp>
-      <mc:AlternateContent xmlns:mc="http://schemas.openxmlformats.org/markup-compatibility/2006">
-        <mc:Choice xmlns:a14="http://schemas.microsoft.com/office/drawing/2010/main" Requires="a14">
+      <mc:AlternateContent xmlns:mc="http://schemas.openxmlformats.org/markup-compatibility/2006" xmlns:a14="http://schemas.microsoft.com/office/drawing/2010/main">
+        <mc:Choice Requires="a14">
           <p:sp>
             <p:nvSpPr>
               <p:cNvPr id="3" name="Content Placeholder 2"/>
@@ -27922,7 +27131,7 @@
                     <m:sSubSup>
                       <m:sSubSupPr>
                         <m:ctrlPr>
-                          <a:rPr lang="ar-AE" i="1">
+                          <a:rPr lang="ar-AE">
                             <a:latin typeface="Cambria Math" panose="02040503050406030204" pitchFamily="18" charset="0"/>
                           </a:rPr>
                         </m:ctrlPr>
@@ -27965,14 +27174,11 @@
                 </a:pPr>
                 <a14:m>
                   <m:oMathPara xmlns:m="http://schemas.openxmlformats.org/officeDocument/2006/math">
-                    <m:oMathParaPr>
-                      <m:jc m:val="centerGroup"/>
-                    </m:oMathParaPr>
-                    <m:oMath xmlns:m="http://schemas.openxmlformats.org/officeDocument/2006/math">
+                    <m:oMath>
                       <m:sSubSup>
                         <m:sSubSupPr>
                           <m:ctrlPr>
-                            <a:rPr lang="ar-AE" i="1" smtClean="0">
+                            <a:rPr lang="ar-AE">
                               <a:latin typeface="Cambria Math" panose="02040503050406030204" pitchFamily="18" charset="0"/>
                             </a:rPr>
                           </m:ctrlPr>
@@ -28006,36 +27212,12 @@
                         <a:rPr lang="ar-AE">
                           <a:latin typeface="Cambria Math" panose="02040503050406030204" pitchFamily="18" charset="0"/>
                         </a:rPr>
-                        <m:t>=</m:t>
-                      </m:r>
-                      <m:r>
-                        <a:rPr lang="ar-AE">
-                          <a:latin typeface="Cambria Math" panose="02040503050406030204" pitchFamily="18" charset="0"/>
-                        </a:rPr>
-                        <m:t>1</m:t>
-                      </m:r>
-                      <m:r>
-                        <a:rPr lang="ar-AE">
-                          <a:latin typeface="Cambria Math" panose="02040503050406030204" pitchFamily="18" charset="0"/>
-                        </a:rPr>
-                        <m:t>.</m:t>
-                      </m:r>
-                      <m:r>
-                        <a:rPr lang="ar-AE">
-                          <a:latin typeface="Cambria Math" panose="02040503050406030204" pitchFamily="18" charset="0"/>
-                        </a:rPr>
-                        <m:t>0</m:t>
-                      </m:r>
-                      <m:r>
-                        <a:rPr lang="ar-AE">
-                          <a:latin typeface="Cambria Math" panose="02040503050406030204" pitchFamily="18" charset="0"/>
-                        </a:rPr>
-                        <m:t>−</m:t>
+                        <m:t>=1.0−</m:t>
                       </m:r>
                       <m:d>
                         <m:dPr>
                           <m:ctrlPr>
-                            <a:rPr lang="ar-AE" i="1" smtClean="0">
+                            <a:rPr lang="ar-AE" b="0" i="1" smtClean="0">
                               <a:latin typeface="Cambria Math" panose="02040503050406030204" pitchFamily="18" charset="0"/>
                             </a:rPr>
                           </m:ctrlPr>
@@ -28083,7 +27265,7 @@
                       <m:f>
                         <m:fPr>
                           <m:ctrlPr>
-                            <a:rPr lang="ar-AE" i="1">
+                            <a:rPr lang="ar-AE">
                               <a:latin typeface="Cambria Math" panose="02040503050406030204" pitchFamily="18" charset="0"/>
                             </a:rPr>
                           </m:ctrlPr>
@@ -28099,13 +27281,7 @@
                             <a:rPr lang="ar-AE">
                               <a:latin typeface="Cambria Math" panose="02040503050406030204" pitchFamily="18" charset="0"/>
                             </a:rPr>
-                            <m:t>−</m:t>
-                          </m:r>
-                          <m:r>
-                            <a:rPr lang="ar-AE">
-                              <a:latin typeface="Cambria Math" panose="02040503050406030204" pitchFamily="18" charset="0"/>
-                            </a:rPr>
-                            <m:t>1</m:t>
+                            <m:t>−1</m:t>
                           </m:r>
                         </m:num>
                         <m:den>
@@ -28197,7 +27373,7 @@
                     <m:sSubSup>
                       <m:sSubSupPr>
                         <m:ctrlPr>
-                          <a:rPr lang="ar-AE" i="1">
+                          <a:rPr lang="ar-AE">
                             <a:latin typeface="Cambria Math" panose="02040503050406030204" pitchFamily="18" charset="0"/>
                           </a:rPr>
                         </m:ctrlPr>
@@ -28247,11 +27423,11 @@
                     <m:oMathParaPr>
                       <m:jc m:val="center"/>
                     </m:oMathParaPr>
-                    <m:oMath xmlns:m="http://schemas.openxmlformats.org/officeDocument/2006/math">
+                    <m:oMath>
                       <m:sSubSup>
                         <m:sSubSupPr>
                           <m:ctrlPr>
-                            <a:rPr lang="ar-AE" i="1">
+                            <a:rPr lang="ar-AE">
                               <a:latin typeface="Cambria Math" panose="02040503050406030204" pitchFamily="18" charset="0"/>
                             </a:rPr>
                           </m:ctrlPr>
@@ -28285,36 +27461,12 @@
                         <a:rPr lang="ar-AE">
                           <a:latin typeface="Cambria Math" panose="02040503050406030204" pitchFamily="18" charset="0"/>
                         </a:rPr>
-                        <m:t>=</m:t>
-                      </m:r>
-                      <m:r>
-                        <a:rPr lang="ar-AE">
-                          <a:latin typeface="Cambria Math" panose="02040503050406030204" pitchFamily="18" charset="0"/>
-                        </a:rPr>
-                        <m:t>1</m:t>
-                      </m:r>
-                      <m:r>
-                        <a:rPr lang="ar-AE">
-                          <a:latin typeface="Cambria Math" panose="02040503050406030204" pitchFamily="18" charset="0"/>
-                        </a:rPr>
-                        <m:t>.</m:t>
-                      </m:r>
-                      <m:r>
-                        <a:rPr lang="ar-AE">
-                          <a:latin typeface="Cambria Math" panose="02040503050406030204" pitchFamily="18" charset="0"/>
-                        </a:rPr>
-                        <m:t>0</m:t>
-                      </m:r>
-                      <m:r>
-                        <a:rPr lang="ar-AE">
-                          <a:latin typeface="Cambria Math" panose="02040503050406030204" pitchFamily="18" charset="0"/>
-                        </a:rPr>
-                        <m:t>−</m:t>
+                        <m:t>=1.0−</m:t>
                       </m:r>
                       <m:f>
                         <m:fPr>
                           <m:ctrlPr>
-                            <a:rPr lang="ar-AE" i="1">
+                            <a:rPr lang="ar-AE">
                               <a:latin typeface="Cambria Math" panose="02040503050406030204" pitchFamily="18" charset="0"/>
                             </a:rPr>
                           </m:ctrlPr>
@@ -28339,7 +27491,7 @@
                       <m:f>
                         <m:fPr>
                           <m:ctrlPr>
-                            <a:rPr lang="ar-AE" i="1">
+                            <a:rPr lang="ar-AE">
                               <a:latin typeface="Cambria Math" panose="02040503050406030204" pitchFamily="18" charset="0"/>
                             </a:rPr>
                           </m:ctrlPr>
@@ -28355,13 +27507,7 @@
                             <a:rPr lang="ar-AE">
                               <a:latin typeface="Cambria Math" panose="02040503050406030204" pitchFamily="18" charset="0"/>
                             </a:rPr>
-                            <m:t>−</m:t>
-                          </m:r>
-                          <m:r>
-                            <a:rPr lang="ar-AE">
-                              <a:latin typeface="Cambria Math" panose="02040503050406030204" pitchFamily="18" charset="0"/>
-                            </a:rPr>
-                            <m:t>1</m:t>
+                            <m:t>−1</m:t>
                           </m:r>
                         </m:num>
                         <m:den>
@@ -28375,19 +27521,7 @@
                             <a:rPr lang="ar-AE">
                               <a:latin typeface="Cambria Math" panose="02040503050406030204" pitchFamily="18" charset="0"/>
                             </a:rPr>
-                            <m:t>−</m:t>
-                          </m:r>
-                          <m:r>
-                            <a:rPr lang="ar-AE">
-                              <a:latin typeface="Cambria Math" panose="02040503050406030204" pitchFamily="18" charset="0"/>
-                            </a:rPr>
-                            <m:t>1</m:t>
-                          </m:r>
-                          <m:r>
-                            <a:rPr lang="ar-AE">
-                              <a:latin typeface="Cambria Math" panose="02040503050406030204" pitchFamily="18" charset="0"/>
-                            </a:rPr>
-                            <m:t>−</m:t>
+                            <m:t>−1−</m:t>
                           </m:r>
                           <m:r>
                             <m:rPr>
@@ -28408,7 +27542,7 @@
             </p:txBody>
           </p:sp>
         </mc:Choice>
-        <mc:Fallback>
+        <mc:Fallback xmlns="">
           <p:sp>
             <p:nvSpPr>
               <p:cNvPr id="3" name="Content Placeholder 2"/>
@@ -28712,8 +27846,8 @@
           </a:p>
         </p:txBody>
       </p:sp>
-      <mc:AlternateContent xmlns:mc="http://schemas.openxmlformats.org/markup-compatibility/2006">
-        <mc:Choice xmlns:a14="http://schemas.microsoft.com/office/drawing/2010/main" Requires="a14">
+      <mc:AlternateContent xmlns:mc="http://schemas.openxmlformats.org/markup-compatibility/2006" xmlns:a14="http://schemas.microsoft.com/office/drawing/2010/main">
+        <mc:Choice Requires="a14">
           <p:sp>
             <p:nvSpPr>
               <p:cNvPr id="5" name="Content Placeholder 4">
@@ -28756,7 +27890,7 @@
                     <m:sSup>
                       <m:sSupPr>
                         <m:ctrlPr>
-                          <a:rPr lang="en-US" sz="2000" i="1" smtClean="0">
+                          <a:rPr lang="en-US" sz="2000" b="0" i="1" smtClean="0">
                             <a:latin typeface="Cambria Math" panose="02040503050406030204" pitchFamily="18" charset="0"/>
                           </a:rPr>
                         </m:ctrlPr>
@@ -28791,7 +27925,7 @@
                     <m:sSubSup>
                       <m:sSubSupPr>
                         <m:ctrlPr>
-                          <a:rPr lang="en-US" sz="2000" i="1" smtClean="0">
+                          <a:rPr lang="en-US" sz="2000" b="0" i="1" smtClean="0">
                             <a:latin typeface="Cambria Math" panose="02040503050406030204" pitchFamily="18" charset="0"/>
                           </a:rPr>
                         </m:ctrlPr>
@@ -28853,7 +27987,7 @@
                     <m:sSub>
                       <m:sSubPr>
                         <m:ctrlPr>
-                          <a:rPr lang="ar-AE" sz="1800" i="1">
+                          <a:rPr lang="ar-AE" sz="1800">
                             <a:latin typeface="Cambria Math" panose="02040503050406030204" pitchFamily="18" charset="0"/>
                           </a:rPr>
                         </m:ctrlPr>
@@ -28904,7 +28038,7 @@
                     <m:sSub>
                       <m:sSubPr>
                         <m:ctrlPr>
-                          <a:rPr lang="ar-AE" sz="1800" i="1">
+                          <a:rPr lang="ar-AE" sz="1800">
                             <a:latin typeface="Cambria Math" panose="02040503050406030204" pitchFamily="18" charset="0"/>
                           </a:rPr>
                         </m:ctrlPr>
@@ -28958,7 +28092,7 @@
                     <m:sSub>
                       <m:sSubPr>
                         <m:ctrlPr>
-                          <a:rPr lang="ar-AE" sz="1800" i="1">
+                          <a:rPr lang="ar-AE" sz="1800">
                             <a:latin typeface="Cambria Math" panose="02040503050406030204" pitchFamily="18" charset="0"/>
                           </a:rPr>
                         </m:ctrlPr>
@@ -28995,7 +28129,7 @@
                     <m:sSub>
                       <m:sSubPr>
                         <m:ctrlPr>
-                          <a:rPr lang="ar-AE" sz="1800" i="1">
+                          <a:rPr lang="ar-AE" sz="1800">
                             <a:latin typeface="Cambria Math" panose="02040503050406030204" pitchFamily="18" charset="0"/>
                           </a:rPr>
                         </m:ctrlPr>
@@ -29075,7 +28209,7 @@
             </p:txBody>
           </p:sp>
         </mc:Choice>
-        <mc:Fallback>
+        <mc:Fallback xmlns="">
           <p:sp>
             <p:nvSpPr>
               <p:cNvPr id="5" name="Content Placeholder 4">
@@ -30461,8 +29595,8 @@
           </a:p>
         </p:txBody>
       </p:sp>
-      <mc:AlternateContent xmlns:mc="http://schemas.openxmlformats.org/markup-compatibility/2006">
-        <mc:Choice xmlns:a14="http://schemas.microsoft.com/office/drawing/2010/main" Requires="a14">
+      <mc:AlternateContent xmlns:mc="http://schemas.openxmlformats.org/markup-compatibility/2006" xmlns:a14="http://schemas.microsoft.com/office/drawing/2010/main">
+        <mc:Choice Requires="a14">
           <p:sp>
             <p:nvSpPr>
               <p:cNvPr id="5" name="Content Placeholder 4">
@@ -30555,13 +29689,7 @@
                       <a:rPr lang="en-US" sz="2000" b="0" i="1" smtClean="0">
                         <a:latin typeface="Cambria Math" panose="02040503050406030204" pitchFamily="18" charset="0"/>
                       </a:rPr>
-                      <m:t>&lt;</m:t>
-                    </m:r>
-                    <m:r>
-                      <a:rPr lang="en-US" sz="2000" b="0" i="1" smtClean="0">
-                        <a:latin typeface="Cambria Math" panose="02040503050406030204" pitchFamily="18" charset="0"/>
-                      </a:rPr>
-                      <m:t>2</m:t>
+                      <m:t>&lt;2</m:t>
                     </m:r>
                   </m:oMath>
                 </a14:m>
@@ -30615,7 +29743,7 @@
             </p:txBody>
           </p:sp>
         </mc:Choice>
-        <mc:Fallback>
+        <mc:Fallback xmlns="">
           <p:sp>
             <p:nvSpPr>
               <p:cNvPr id="5" name="Content Placeholder 4">
@@ -31291,7 +30419,7 @@
                     <m:oMathParaPr>
                       <m:jc m:val="center"/>
                     </m:oMathParaPr>
-                    <m:oMath xmlns:m="http://schemas.openxmlformats.org/officeDocument/2006/math">
+                    <m:oMath>
                       <m:r>
                         <a:rPr lang="en-US" sz="2900">
                           <a:latin typeface="Cambria Math" panose="02040503050406030204" pitchFamily="18" charset="0"/>
@@ -31307,7 +30435,7 @@
                       <m:rad>
                         <m:radPr>
                           <m:ctrlPr>
-                            <a:rPr lang="ar-AE" sz="2900" i="1">
+                            <a:rPr lang="ar-AE" sz="2900" b="0" i="1" smtClean="0">
                               <a:latin typeface="Cambria Math" panose="02040503050406030204" pitchFamily="18" charset="0"/>
                             </a:rPr>
                           </m:ctrlPr>
@@ -31336,7 +30464,7 @@
                               <m:sSubSup>
                                 <m:sSubSupPr>
                                   <m:ctrlPr>
-                                    <a:rPr lang="ar-AE" sz="2900" i="1">
+                                    <a:rPr lang="ar-AE" sz="2900">
                                       <a:latin typeface="Cambria Math" panose="02040503050406030204" pitchFamily="18" charset="0"/>
                                     </a:rPr>
                                   </m:ctrlPr>
@@ -31360,13 +30488,7 @@
                                     <a:rPr lang="ar-AE" sz="2900">
                                       <a:latin typeface="Cambria Math" panose="02040503050406030204" pitchFamily="18" charset="0"/>
                                     </a:rPr>
-                                    <m:t>−</m:t>
-                                  </m:r>
-                                  <m:r>
-                                    <a:rPr lang="ar-AE" sz="2900">
-                                      <a:latin typeface="Cambria Math" panose="02040503050406030204" pitchFamily="18" charset="0"/>
-                                    </a:rPr>
-                                    <m:t>1</m:t>
+                                    <m:t>−1</m:t>
                                   </m:r>
                                 </m:sub>
                                 <m:sup>
@@ -31399,7 +30521,7 @@
                                       <m:sSub>
                                         <m:sSubPr>
                                           <m:ctrlPr>
-                                            <a:rPr lang="ar-AE" sz="2900" i="1">
+                                            <a:rPr lang="ar-AE" sz="2900">
                                               <a:latin typeface="Cambria Math" panose="02040503050406030204" pitchFamily="18" charset="0"/>
                                             </a:rPr>
                                           </m:ctrlPr>
@@ -31440,7 +30562,7 @@
                                           <m:sSub>
                                             <m:sSubPr>
                                               <m:ctrlPr>
-                                                <a:rPr lang="ar-AE" sz="2900" i="1">
+                                                <a:rPr lang="ar-AE" sz="2900">
                                                   <a:latin typeface="Cambria Math" panose="02040503050406030204" pitchFamily="18" charset="0"/>
                                                 </a:rPr>
                                               </m:ctrlPr>
@@ -31497,7 +30619,7 @@
                       <m:rad>
                         <m:radPr>
                           <m:ctrlPr>
-                            <a:rPr lang="ar-AE" sz="2900" i="1">
+                            <a:rPr lang="en-US" sz="2900" b="0" i="1" smtClean="0">
                               <a:latin typeface="Cambria Math" panose="02040503050406030204" pitchFamily="18" charset="0"/>
                             </a:rPr>
                           </m:ctrlPr>
@@ -31517,7 +30639,7 @@
                           <m:f>
                             <m:fPr>
                               <m:ctrlPr>
-                                <a:rPr lang="ar-AE" sz="2900" i="1">
+                                <a:rPr lang="ar-AE" sz="2900">
                                   <a:latin typeface="Cambria Math" panose="02040503050406030204" pitchFamily="18" charset="0"/>
                                 </a:rPr>
                               </m:ctrlPr>
@@ -31733,7 +30855,7 @@
                     <m:oMathParaPr>
                       <m:jc m:val="center"/>
                     </m:oMathParaPr>
-                    <m:oMath xmlns:m="http://schemas.openxmlformats.org/officeDocument/2006/math">
+                    <m:oMath>
                       <m:r>
                         <a:rPr lang="en-US" sz="2900">
                           <a:latin typeface="Cambria Math" panose="02040503050406030204" pitchFamily="18" charset="0"/>
@@ -31777,7 +30899,7 @@
                               <m:sSub>
                                 <m:sSubPr>
                                   <m:ctrlPr>
-                                    <a:rPr lang="ar-AE" sz="2900" i="1">
+                                    <a:rPr lang="ar-AE" sz="2900">
                                       <a:latin typeface="Cambria Math" panose="02040503050406030204" pitchFamily="18" charset="0"/>
                                     </a:rPr>
                                   </m:ctrlPr>
@@ -31818,7 +30940,7 @@
                                   <m:sSub>
                                     <m:sSubPr>
                                       <m:ctrlPr>
-                                        <a:rPr lang="ar-AE" sz="2900" i="1">
+                                        <a:rPr lang="ar-AE" sz="2900">
                                           <a:latin typeface="Cambria Math" panose="02040503050406030204" pitchFamily="18" charset="0"/>
                                         </a:rPr>
                                       </m:ctrlPr>
@@ -34041,13 +33163,7 @@
                       <a:rPr>
                         <a:latin typeface="Cambria Math" panose="02040503050406030204" pitchFamily="18" charset="0"/>
                       </a:rPr>
-                      <m:t>+</m:t>
-                    </m:r>
-                    <m:r>
-                      <a:rPr>
-                        <a:latin typeface="Cambria Math" panose="02040503050406030204" pitchFamily="18" charset="0"/>
-                      </a:rPr>
-                      <m:t>1</m:t>
+                      <m:t>+1</m:t>
                     </m:r>
                   </m:oMath>
                 </a14:m>
@@ -34065,12 +33181,12 @@
                     <m:oMathParaPr>
                       <m:jc m:val="center"/>
                     </m:oMathParaPr>
-                    <m:oMath xmlns:m="http://schemas.openxmlformats.org/officeDocument/2006/math">
+                    <m:oMath>
                       <m:acc>
                         <m:accPr>
                           <m:chr m:val="⃗"/>
                           <m:ctrlPr>
-                            <a:rPr i="1">
+                            <a:rPr>
                               <a:latin typeface="Cambria Math" panose="02040503050406030204" pitchFamily="18" charset="0"/>
                             </a:rPr>
                           </m:ctrlPr>
@@ -34104,7 +33220,7 @@
                           <m:sSub>
                             <m:sSubPr>
                               <m:ctrlPr>
-                                <a:rPr i="1">
+                                <a:rPr>
                                   <a:latin typeface="Cambria Math" panose="02040503050406030204" pitchFamily="18" charset="0"/>
                                 </a:rPr>
                               </m:ctrlPr>
@@ -34135,7 +33251,7 @@
                           <m:sSub>
                             <m:sSubPr>
                               <m:ctrlPr>
-                                <a:rPr i="1">
+                                <a:rPr>
                                   <a:latin typeface="Cambria Math" panose="02040503050406030204" pitchFamily="18" charset="0"/>
                                 </a:rPr>
                               </m:ctrlPr>
@@ -34166,7 +33282,7 @@
                           <m:sSub>
                             <m:sSubPr>
                               <m:ctrlPr>
-                                <a:rPr i="1">
+                                <a:rPr>
                                   <a:latin typeface="Cambria Math" panose="02040503050406030204" pitchFamily="18" charset="0"/>
                                 </a:rPr>
                               </m:ctrlPr>
@@ -34197,7 +33313,7 @@
                           <m:sSub>
                             <m:sSubPr>
                               <m:ctrlPr>
-                                <a:rPr i="1">
+                                <a:rPr>
                                   <a:latin typeface="Cambria Math" panose="02040503050406030204" pitchFamily="18" charset="0"/>
                                 </a:rPr>
                               </m:ctrlPr>
@@ -34256,7 +33372,7 @@
                     <m:oMathParaPr>
                       <m:jc m:val="center"/>
                     </m:oMathParaPr>
-                    <m:oMath xmlns:m="http://schemas.openxmlformats.org/officeDocument/2006/math">
+                    <m:oMath>
                       <m:r>
                         <a:rPr>
                           <a:latin typeface="Cambria Math" panose="02040503050406030204" pitchFamily="18" charset="0"/>
@@ -34302,18 +33418,12 @@
                                   <a:rPr>
                                     <a:latin typeface="Cambria Math" panose="02040503050406030204" pitchFamily="18" charset="0"/>
                                   </a:rPr>
-                                  <m:t>1</m:t>
-                                </m:r>
-                                <m:r>
-                                  <a:rPr>
-                                    <a:latin typeface="Cambria Math" panose="02040503050406030204" pitchFamily="18" charset="0"/>
-                                  </a:rPr>
-                                  <m:t>,</m:t>
+                                  <m:t>1,</m:t>
                                 </m:r>
                                 <m:sSub>
                                   <m:sSubPr>
                                     <m:ctrlPr>
-                                      <a:rPr i="1">
+                                      <a:rPr>
                                         <a:latin typeface="Cambria Math" panose="02040503050406030204" pitchFamily="18" charset="0"/>
                                       </a:rPr>
                                     </m:ctrlPr>
@@ -34331,19 +33441,7 @@
                                       <a:rPr>
                                         <a:latin typeface="Cambria Math" panose="02040503050406030204" pitchFamily="18" charset="0"/>
                                       </a:rPr>
-                                      <m:t>1</m:t>
-                                    </m:r>
-                                    <m:r>
-                                      <a:rPr>
-                                        <a:latin typeface="Cambria Math" panose="02040503050406030204" pitchFamily="18" charset="0"/>
-                                      </a:rPr>
-                                      <m:t>,</m:t>
-                                    </m:r>
-                                    <m:r>
-                                      <a:rPr>
-                                        <a:latin typeface="Cambria Math" panose="02040503050406030204" pitchFamily="18" charset="0"/>
-                                      </a:rPr>
-                                      <m:t>1</m:t>
+                                      <m:t>1,1</m:t>
                                     </m:r>
                                   </m:sub>
                                 </m:sSub>
@@ -34356,7 +33454,7 @@
                                 <m:sSub>
                                   <m:sSubPr>
                                     <m:ctrlPr>
-                                      <a:rPr i="1">
+                                      <a:rPr>
                                         <a:latin typeface="Cambria Math" panose="02040503050406030204" pitchFamily="18" charset="0"/>
                                       </a:rPr>
                                     </m:ctrlPr>
@@ -34374,19 +33472,7 @@
                                       <a:rPr>
                                         <a:latin typeface="Cambria Math" panose="02040503050406030204" pitchFamily="18" charset="0"/>
                                       </a:rPr>
-                                      <m:t>1</m:t>
-                                    </m:r>
-                                    <m:r>
-                                      <a:rPr>
-                                        <a:latin typeface="Cambria Math" panose="02040503050406030204" pitchFamily="18" charset="0"/>
-                                      </a:rPr>
-                                      <m:t>,</m:t>
-                                    </m:r>
-                                    <m:r>
-                                      <a:rPr>
-                                        <a:latin typeface="Cambria Math" panose="02040503050406030204" pitchFamily="18" charset="0"/>
-                                      </a:rPr>
-                                      <m:t>2</m:t>
+                                      <m:t>1,2</m:t>
                                     </m:r>
                                   </m:sub>
                                 </m:sSub>
@@ -34399,7 +33485,7 @@
                                 <m:sSub>
                                   <m:sSubPr>
                                     <m:ctrlPr>
-                                      <a:rPr i="1">
+                                      <a:rPr>
                                         <a:latin typeface="Cambria Math" panose="02040503050406030204" pitchFamily="18" charset="0"/>
                                       </a:rPr>
                                     </m:ctrlPr>
@@ -34417,13 +33503,7 @@
                                       <a:rPr>
                                         <a:latin typeface="Cambria Math" panose="02040503050406030204" pitchFamily="18" charset="0"/>
                                       </a:rPr>
-                                      <m:t>1</m:t>
-                                    </m:r>
-                                    <m:r>
-                                      <a:rPr>
-                                        <a:latin typeface="Cambria Math" panose="02040503050406030204" pitchFamily="18" charset="0"/>
-                                      </a:rPr>
-                                      <m:t>,</m:t>
+                                      <m:t>1,</m:t>
                                     </m:r>
                                     <m:r>
                                       <a:rPr>
@@ -34441,18 +33521,12 @@
                                   <a:rPr>
                                     <a:latin typeface="Cambria Math" panose="02040503050406030204" pitchFamily="18" charset="0"/>
                                   </a:rPr>
-                                  <m:t>1</m:t>
-                                </m:r>
-                                <m:r>
-                                  <a:rPr>
-                                    <a:latin typeface="Cambria Math" panose="02040503050406030204" pitchFamily="18" charset="0"/>
-                                  </a:rPr>
-                                  <m:t>,</m:t>
+                                  <m:t>1,</m:t>
                                 </m:r>
                                 <m:sSub>
                                   <m:sSubPr>
                                     <m:ctrlPr>
-                                      <a:rPr i="1">
+                                      <a:rPr>
                                         <a:latin typeface="Cambria Math" panose="02040503050406030204" pitchFamily="18" charset="0"/>
                                       </a:rPr>
                                     </m:ctrlPr>
@@ -34470,19 +33544,7 @@
                                       <a:rPr>
                                         <a:latin typeface="Cambria Math" panose="02040503050406030204" pitchFamily="18" charset="0"/>
                                       </a:rPr>
-                                      <m:t>2</m:t>
-                                    </m:r>
-                                    <m:r>
-                                      <a:rPr>
-                                        <a:latin typeface="Cambria Math" panose="02040503050406030204" pitchFamily="18" charset="0"/>
-                                      </a:rPr>
-                                      <m:t>,</m:t>
-                                    </m:r>
-                                    <m:r>
-                                      <a:rPr>
-                                        <a:latin typeface="Cambria Math" panose="02040503050406030204" pitchFamily="18" charset="0"/>
-                                      </a:rPr>
-                                      <m:t>1</m:t>
+                                      <m:t>2,1</m:t>
                                     </m:r>
                                   </m:sub>
                                 </m:sSub>
@@ -34495,7 +33557,7 @@
                                 <m:sSub>
                                   <m:sSubPr>
                                     <m:ctrlPr>
-                                      <a:rPr i="1">
+                                      <a:rPr>
                                         <a:latin typeface="Cambria Math" panose="02040503050406030204" pitchFamily="18" charset="0"/>
                                       </a:rPr>
                                     </m:ctrlPr>
@@ -34513,19 +33575,7 @@
                                       <a:rPr>
                                         <a:latin typeface="Cambria Math" panose="02040503050406030204" pitchFamily="18" charset="0"/>
                                       </a:rPr>
-                                      <m:t>2</m:t>
-                                    </m:r>
-                                    <m:r>
-                                      <a:rPr>
-                                        <a:latin typeface="Cambria Math" panose="02040503050406030204" pitchFamily="18" charset="0"/>
-                                      </a:rPr>
-                                      <m:t>,</m:t>
-                                    </m:r>
-                                    <m:r>
-                                      <a:rPr>
-                                        <a:latin typeface="Cambria Math" panose="02040503050406030204" pitchFamily="18" charset="0"/>
-                                      </a:rPr>
-                                      <m:t>2</m:t>
+                                      <m:t>2,2</m:t>
                                     </m:r>
                                   </m:sub>
                                 </m:sSub>
@@ -34538,7 +33588,7 @@
                                 <m:sSub>
                                   <m:sSubPr>
                                     <m:ctrlPr>
-                                      <a:rPr i="1">
+                                      <a:rPr>
                                         <a:latin typeface="Cambria Math" panose="02040503050406030204" pitchFamily="18" charset="0"/>
                                       </a:rPr>
                                     </m:ctrlPr>
@@ -34556,13 +33606,7 @@
                                       <a:rPr>
                                         <a:latin typeface="Cambria Math" panose="02040503050406030204" pitchFamily="18" charset="0"/>
                                       </a:rPr>
-                                      <m:t>2</m:t>
-                                    </m:r>
-                                    <m:r>
-                                      <a:rPr>
-                                        <a:latin typeface="Cambria Math" panose="02040503050406030204" pitchFamily="18" charset="0"/>
-                                      </a:rPr>
-                                      <m:t>,</m:t>
+                                      <m:t>2,</m:t>
                                     </m:r>
                                     <m:r>
                                       <a:rPr>
@@ -34580,18 +33624,12 @@
                                   <a:rPr>
                                     <a:latin typeface="Cambria Math" panose="02040503050406030204" pitchFamily="18" charset="0"/>
                                   </a:rPr>
-                                  <m:t>1</m:t>
-                                </m:r>
-                                <m:r>
-                                  <a:rPr>
-                                    <a:latin typeface="Cambria Math" panose="02040503050406030204" pitchFamily="18" charset="0"/>
-                                  </a:rPr>
-                                  <m:t>,</m:t>
+                                  <m:t>1,</m:t>
                                 </m:r>
                                 <m:sSub>
                                   <m:sSubPr>
                                     <m:ctrlPr>
-                                      <a:rPr i="1">
+                                      <a:rPr>
                                         <a:latin typeface="Cambria Math" panose="02040503050406030204" pitchFamily="18" charset="0"/>
                                       </a:rPr>
                                     </m:ctrlPr>
@@ -34609,19 +33647,7 @@
                                       <a:rPr>
                                         <a:latin typeface="Cambria Math" panose="02040503050406030204" pitchFamily="18" charset="0"/>
                                       </a:rPr>
-                                      <m:t>3</m:t>
-                                    </m:r>
-                                    <m:r>
-                                      <a:rPr>
-                                        <a:latin typeface="Cambria Math" panose="02040503050406030204" pitchFamily="18" charset="0"/>
-                                      </a:rPr>
-                                      <m:t>,</m:t>
-                                    </m:r>
-                                    <m:r>
-                                      <a:rPr>
-                                        <a:latin typeface="Cambria Math" panose="02040503050406030204" pitchFamily="18" charset="0"/>
-                                      </a:rPr>
-                                      <m:t>1</m:t>
+                                      <m:t>3,1</m:t>
                                     </m:r>
                                   </m:sub>
                                 </m:sSub>
@@ -34634,7 +33660,7 @@
                                 <m:sSub>
                                   <m:sSubPr>
                                     <m:ctrlPr>
-                                      <a:rPr i="1">
+                                      <a:rPr>
                                         <a:latin typeface="Cambria Math" panose="02040503050406030204" pitchFamily="18" charset="0"/>
                                       </a:rPr>
                                     </m:ctrlPr>
@@ -34652,19 +33678,7 @@
                                       <a:rPr>
                                         <a:latin typeface="Cambria Math" panose="02040503050406030204" pitchFamily="18" charset="0"/>
                                       </a:rPr>
-                                      <m:t>3</m:t>
-                                    </m:r>
-                                    <m:r>
-                                      <a:rPr>
-                                        <a:latin typeface="Cambria Math" panose="02040503050406030204" pitchFamily="18" charset="0"/>
-                                      </a:rPr>
-                                      <m:t>,</m:t>
-                                    </m:r>
-                                    <m:r>
-                                      <a:rPr>
-                                        <a:latin typeface="Cambria Math" panose="02040503050406030204" pitchFamily="18" charset="0"/>
-                                      </a:rPr>
-                                      <m:t>2</m:t>
+                                      <m:t>3,2</m:t>
                                     </m:r>
                                   </m:sub>
                                 </m:sSub>
@@ -34677,7 +33691,7 @@
                                 <m:sSub>
                                   <m:sSubPr>
                                     <m:ctrlPr>
-                                      <a:rPr i="1">
+                                      <a:rPr>
                                         <a:latin typeface="Cambria Math" panose="02040503050406030204" pitchFamily="18" charset="0"/>
                                       </a:rPr>
                                     </m:ctrlPr>
@@ -34695,13 +33709,7 @@
                                       <a:rPr>
                                         <a:latin typeface="Cambria Math" panose="02040503050406030204" pitchFamily="18" charset="0"/>
                                       </a:rPr>
-                                      <m:t>3</m:t>
-                                    </m:r>
-                                    <m:r>
-                                      <a:rPr>
-                                        <a:latin typeface="Cambria Math" panose="02040503050406030204" pitchFamily="18" charset="0"/>
-                                      </a:rPr>
-                                      <m:t>,</m:t>
+                                      <m:t>3,</m:t>
                                     </m:r>
                                     <m:r>
                                       <a:rPr>
@@ -34729,18 +33737,12 @@
                                   <a:rPr>
                                     <a:latin typeface="Cambria Math" panose="02040503050406030204" pitchFamily="18" charset="0"/>
                                   </a:rPr>
-                                  <m:t>1</m:t>
-                                </m:r>
-                                <m:r>
-                                  <a:rPr>
-                                    <a:latin typeface="Cambria Math" panose="02040503050406030204" pitchFamily="18" charset="0"/>
-                                  </a:rPr>
-                                  <m:t>,</m:t>
+                                  <m:t>1,</m:t>
                                 </m:r>
                                 <m:sSub>
                                   <m:sSubPr>
                                     <m:ctrlPr>
-                                      <a:rPr i="1">
+                                      <a:rPr>
                                         <a:latin typeface="Cambria Math" panose="02040503050406030204" pitchFamily="18" charset="0"/>
                                       </a:rPr>
                                     </m:ctrlPr>
@@ -34764,13 +33766,7 @@
                                       <a:rPr>
                                         <a:latin typeface="Cambria Math" panose="02040503050406030204" pitchFamily="18" charset="0"/>
                                       </a:rPr>
-                                      <m:t>,</m:t>
-                                    </m:r>
-                                    <m:r>
-                                      <a:rPr>
-                                        <a:latin typeface="Cambria Math" panose="02040503050406030204" pitchFamily="18" charset="0"/>
-                                      </a:rPr>
-                                      <m:t>1</m:t>
+                                      <m:t>,1</m:t>
                                     </m:r>
                                   </m:sub>
                                 </m:sSub>
@@ -34783,7 +33779,7 @@
                                 <m:sSub>
                                   <m:sSubPr>
                                     <m:ctrlPr>
-                                      <a:rPr i="1">
+                                      <a:rPr>
                                         <a:latin typeface="Cambria Math" panose="02040503050406030204" pitchFamily="18" charset="0"/>
                                       </a:rPr>
                                     </m:ctrlPr>
@@ -34807,13 +33803,7 @@
                                       <a:rPr>
                                         <a:latin typeface="Cambria Math" panose="02040503050406030204" pitchFamily="18" charset="0"/>
                                       </a:rPr>
-                                      <m:t>,</m:t>
-                                    </m:r>
-                                    <m:r>
-                                      <a:rPr>
-                                        <a:latin typeface="Cambria Math" panose="02040503050406030204" pitchFamily="18" charset="0"/>
-                                      </a:rPr>
-                                      <m:t>2</m:t>
+                                      <m:t>,2</m:t>
                                     </m:r>
                                   </m:sub>
                                 </m:sSub>
@@ -34826,7 +33816,7 @@
                                 <m:sSub>
                                   <m:sSubPr>
                                     <m:ctrlPr>
-                                      <a:rPr i="1">
+                                      <a:rPr>
                                         <a:latin typeface="Cambria Math" panose="02040503050406030204" pitchFamily="18" charset="0"/>
                                       </a:rPr>
                                     </m:ctrlPr>
@@ -34903,13 +33893,7 @@
                       <a:rPr>
                         <a:latin typeface="Cambria Math" panose="02040503050406030204" pitchFamily="18" charset="0"/>
                       </a:rPr>
-                      <m:t>+</m:t>
-                    </m:r>
-                    <m:r>
-                      <a:rPr>
-                        <a:latin typeface="Cambria Math" panose="02040503050406030204" pitchFamily="18" charset="0"/>
-                      </a:rPr>
-                      <m:t>1</m:t>
+                      <m:t>+1</m:t>
                     </m:r>
                   </m:oMath>
                 </a14:m>
@@ -34929,13 +33913,7 @@
                       <a:rPr>
                         <a:latin typeface="Cambria Math" panose="02040503050406030204" pitchFamily="18" charset="0"/>
                       </a:rPr>
-                      <m:t>+</m:t>
-                    </m:r>
-                    <m:r>
-                      <a:rPr>
-                        <a:latin typeface="Cambria Math" panose="02040503050406030204" pitchFamily="18" charset="0"/>
-                      </a:rPr>
-                      <m:t>1</m:t>
+                      <m:t>+1</m:t>
                     </m:r>
                   </m:oMath>
                 </a14:m>
@@ -35381,10 +34359,7 @@
                 <a:pPr lvl="0"/>
                 <a14:m>
                   <m:oMathPara xmlns:m="http://schemas.openxmlformats.org/officeDocument/2006/math">
-                    <m:oMathParaPr>
-                      <m:jc m:val="centerGroup"/>
-                    </m:oMathParaPr>
-                    <m:oMath xmlns:m="http://schemas.openxmlformats.org/officeDocument/2006/math">
+                    <m:oMath>
                       <m:r>
                         <a:rPr lang="en-US" sz="2000" b="0" i="1" smtClean="0">
                           <a:latin typeface="Cambria Math" panose="02040503050406030204" pitchFamily="18" charset="0"/>
@@ -35888,10 +34863,7 @@
                 </a:pPr>
                 <a14:m>
                   <m:oMathPara xmlns:m="http://schemas.openxmlformats.org/officeDocument/2006/math">
-                    <m:oMathParaPr>
-                      <m:jc m:val="centerGroup"/>
-                    </m:oMathParaPr>
-                    <m:oMath xmlns:m="http://schemas.openxmlformats.org/officeDocument/2006/math">
+                    <m:oMath>
                       <m:r>
                         <a:rPr lang="en-US" sz="2000" b="0" i="1" smtClean="0">
                           <a:latin typeface="Cambria Math" panose="02040503050406030204" pitchFamily="18" charset="0"/>
@@ -35999,15 +34971,12 @@
                 <a:pPr lvl="0"/>
                 <a14:m>
                   <m:oMathPara xmlns:m="http://schemas.openxmlformats.org/officeDocument/2006/math">
-                    <m:oMathParaPr>
-                      <m:jc m:val="centerGroup"/>
-                    </m:oMathParaPr>
-                    <m:oMath xmlns:m="http://schemas.openxmlformats.org/officeDocument/2006/math">
+                    <m:oMath>
                       <m:acc>
                         <m:accPr>
                           <m:chr m:val="⃑"/>
                           <m:ctrlPr>
-                            <a:rPr lang="en-US" sz="2000" i="1" smtClean="0">
+                            <a:rPr lang="en-US" sz="2000" b="0" i="1" smtClean="0">
                               <a:latin typeface="Cambria Math" panose="02040503050406030204" pitchFamily="18" charset="0"/>
                             </a:rPr>
                           </m:ctrlPr>
@@ -36043,6 +35012,7 @@
                               <m:ctrlPr>
                                 <a:rPr lang="en-US" sz="2000" b="0" i="1" smtClean="0">
                                   <a:latin typeface="Cambria Math" panose="02040503050406030204" pitchFamily="18" charset="0"/>
+                                  <a:ea typeface="Cambria Math" panose="02040503050406030204" pitchFamily="18" charset="0"/>
                                 </a:rPr>
                               </m:ctrlPr>
                             </m:sSubPr>
@@ -36075,6 +35045,7 @@
                               <m:ctrlPr>
                                 <a:rPr lang="en-US" sz="2000" i="1">
                                   <a:latin typeface="Cambria Math" panose="02040503050406030204" pitchFamily="18" charset="0"/>
+                                  <a:ea typeface="Cambria Math" panose="02040503050406030204" pitchFamily="18" charset="0"/>
                                 </a:rPr>
                               </m:ctrlPr>
                             </m:sSubPr>
@@ -36108,6 +35079,7 @@
                               <m:ctrlPr>
                                 <a:rPr lang="en-US" sz="2000" i="1">
                                   <a:latin typeface="Cambria Math" panose="02040503050406030204" pitchFamily="18" charset="0"/>
+                                  <a:ea typeface="Cambria Math" panose="02040503050406030204" pitchFamily="18" charset="0"/>
                                 </a:rPr>
                               </m:ctrlPr>
                             </m:sSubPr>
@@ -37505,7 +36477,7 @@
                     <m:sSup>
                       <m:sSupPr>
                         <m:ctrlPr>
-                          <a:rPr lang="en-US" sz="2000" i="1" smtClean="0">
+                          <a:rPr lang="en-US" sz="2000" b="0" i="1" smtClean="0">
                             <a:latin typeface="Cambria Math" panose="02040503050406030204" pitchFamily="18" charset="0"/>
                           </a:rPr>
                         </m:ctrlPr>
@@ -37538,7 +36510,7 @@
                     <m:sSubSup>
                       <m:sSubSupPr>
                         <m:ctrlPr>
-                          <a:rPr lang="en-US" sz="2000" i="1" smtClean="0">
+                          <a:rPr lang="en-US" sz="2000" b="0" i="1" smtClean="0">
                             <a:latin typeface="Cambria Math" panose="02040503050406030204" pitchFamily="18" charset="0"/>
                           </a:rPr>
                         </m:ctrlPr>
@@ -41470,7 +40442,7 @@
                     <m:sSup>
                       <m:sSupPr>
                         <m:ctrlPr>
-                          <a:rPr i="1">
+                          <a:rPr>
                             <a:latin typeface="Cambria Math" panose="02040503050406030204" pitchFamily="18" charset="0"/>
                           </a:rPr>
                         </m:ctrlPr>

</xml_diff>